<commit_message>
vault backup: 2026-07-22 17:30:34
</commit_message>
<xml_diff>
--- a/outputs/COGS100_Group8_Piaget_Vygotsky.pptx
+++ b/outputs/COGS100_Group8_Piaget_Vygotsky.pptx
@@ -2,24 +2,24 @@
 <file path=ppt/presentation.xml><?xml version="1.0" encoding="utf-8"?>
 <p:presentation xmlns:p="http://schemas.openxmlformats.org/presentationml/2006/main">
   <p:sldMasterIdLst>
-    <p:sldMasterId xmlns:r="http://schemas.openxmlformats.org/officeDocument/2006/relationships" id="2147483648" r:id="R9951b7e5151e4149"/>
+    <p:sldMasterId xmlns:r="http://schemas.openxmlformats.org/officeDocument/2006/relationships" id="2147483648" r:id="Ra681af0f6e9743d4"/>
   </p:sldMasterIdLst>
   <p:notesMasterIdLst>
-    <p:notesMasterId xmlns:r="http://schemas.openxmlformats.org/officeDocument/2006/relationships" r:id="Raa06446c988b4317"/>
+    <p:notesMasterId xmlns:r="http://schemas.openxmlformats.org/officeDocument/2006/relationships" r:id="Rd9f750a21dae4683"/>
   </p:notesMasterIdLst>
   <p:sldIdLst>
-    <p:sldId xmlns:r="http://schemas.openxmlformats.org/officeDocument/2006/relationships" id="256" r:id="R5aad6af8de0c4618"/>
-    <p:sldId xmlns:r="http://schemas.openxmlformats.org/officeDocument/2006/relationships" id="257" r:id="R4138c7a58ace43a5"/>
-    <p:sldId xmlns:r="http://schemas.openxmlformats.org/officeDocument/2006/relationships" id="258" r:id="R5d39bf43a83c419a"/>
-    <p:sldId xmlns:r="http://schemas.openxmlformats.org/officeDocument/2006/relationships" id="259" r:id="Rdc137136539348ac"/>
-    <p:sldId xmlns:r="http://schemas.openxmlformats.org/officeDocument/2006/relationships" id="260" r:id="R35802c9f52074e22"/>
-    <p:sldId xmlns:r="http://schemas.openxmlformats.org/officeDocument/2006/relationships" id="261" r:id="R5467054a85564f0a"/>
-    <p:sldId xmlns:r="http://schemas.openxmlformats.org/officeDocument/2006/relationships" id="262" r:id="Ra3dda36856ed4ba0"/>
-    <p:sldId xmlns:r="http://schemas.openxmlformats.org/officeDocument/2006/relationships" id="263" r:id="R6f12d5bb8ca840eb"/>
-    <p:sldId xmlns:r="http://schemas.openxmlformats.org/officeDocument/2006/relationships" id="264" r:id="R92d1fe8c62a34cb4"/>
-    <p:sldId xmlns:r="http://schemas.openxmlformats.org/officeDocument/2006/relationships" id="265" r:id="Rfb46024fecaa4acd"/>
-    <p:sldId xmlns:r="http://schemas.openxmlformats.org/officeDocument/2006/relationships" id="266" r:id="Rd2300f567b384d1f"/>
-    <p:sldId xmlns:r="http://schemas.openxmlformats.org/officeDocument/2006/relationships" id="267" r:id="R6379411e580248ec"/>
+    <p:sldId xmlns:r="http://schemas.openxmlformats.org/officeDocument/2006/relationships" id="256" r:id="R5566144c79f4415f"/>
+    <p:sldId xmlns:r="http://schemas.openxmlformats.org/officeDocument/2006/relationships" id="257" r:id="Rc7ea33f499974801"/>
+    <p:sldId xmlns:r="http://schemas.openxmlformats.org/officeDocument/2006/relationships" id="258" r:id="Rabaee7558dfd4a6f"/>
+    <p:sldId xmlns:r="http://schemas.openxmlformats.org/officeDocument/2006/relationships" id="259" r:id="R46c71b9f42c34c28"/>
+    <p:sldId xmlns:r="http://schemas.openxmlformats.org/officeDocument/2006/relationships" id="260" r:id="Rf5253c1d269a429f"/>
+    <p:sldId xmlns:r="http://schemas.openxmlformats.org/officeDocument/2006/relationships" id="261" r:id="Recab8e448bfe4dec"/>
+    <p:sldId xmlns:r="http://schemas.openxmlformats.org/officeDocument/2006/relationships" id="262" r:id="R7820968ea0d0409e"/>
+    <p:sldId xmlns:r="http://schemas.openxmlformats.org/officeDocument/2006/relationships" id="263" r:id="R4e6ffba04dbd4818"/>
+    <p:sldId xmlns:r="http://schemas.openxmlformats.org/officeDocument/2006/relationships" id="264" r:id="R389bfa116a5f41cf"/>
+    <p:sldId xmlns:r="http://schemas.openxmlformats.org/officeDocument/2006/relationships" id="265" r:id="R6d29dadfcef54b97"/>
+    <p:sldId xmlns:r="http://schemas.openxmlformats.org/officeDocument/2006/relationships" id="266" r:id="R055cf56821e94c2e"/>
+    <p:sldId xmlns:r="http://schemas.openxmlformats.org/officeDocument/2006/relationships" id="267" r:id="Rfc2b026788a148d7"/>
   </p:sldIdLst>
   <p:sldSz cx="12192000" cy="6858000"/>
   <p:notesSz cx="6858000" cy="9144000"/>
@@ -1706,7 +1706,7 @@
   </p:cSld>
   <p:clrMap bg1="lt1" tx1="dk1" bg2="lt2" tx2="dk2" accent1="accent1" accent2="accent2" accent3="accent3" accent4="accent4" accent5="accent5" accent6="accent6" hlink="hlink" folHlink="folHlink"/>
   <p:sldLayoutIdLst>
-    <p:sldLayoutId xmlns:r="http://schemas.openxmlformats.org/officeDocument/2006/relationships" id="2147483649" r:id="Rfd49d1e4369d4b6d"/>
+    <p:sldLayoutId xmlns:r="http://schemas.openxmlformats.org/officeDocument/2006/relationships" id="2147483649" r:id="Rcbdae52f821a479e"/>
   </p:sldLayoutIdLst>
   <p:txStyles>
     <p:titleStyle>
@@ -2257,7 +2257,7 @@
           <p:cNvPr id="11" name="">
             <a:extLst xmlns:a="http://schemas.openxmlformats.org/drawingml/2006/main">
               <a:ext uri="{FF2B5EF4-FFF2-40B4-BE49-F238E27FC236}">
-                <a16:creationId xmlns:a16="http://schemas.microsoft.com/office/drawing/2014/main" id="{549F51B6-ACE5-45B6-9E81-2BCBCD7D381B}"/>
+                <a16:creationId xmlns:a16="http://schemas.microsoft.com/office/drawing/2014/main" id="{8D3686CD-7741-43A9-A58D-FD30E61626F0}"/>
               </a:ext>
             </a:extLst>
           </p:cNvPr>
@@ -2315,7 +2315,7 @@
           <p:cNvPr id="2" name="">
             <a:extLst xmlns:a="http://schemas.openxmlformats.org/drawingml/2006/main">
               <a:ext uri="{FF2B5EF4-FFF2-40B4-BE49-F238E27FC236}">
-                <a16:creationId xmlns:a16="http://schemas.microsoft.com/office/drawing/2014/main" id="{754A3077-AC30-4885-8754-4495781A8B8E}"/>
+                <a16:creationId xmlns:a16="http://schemas.microsoft.com/office/drawing/2014/main" id="{38053F9D-AE3F-4D01-BD1F-BE98E8772458}"/>
               </a:ext>
             </a:extLst>
           </p:cNvPr>
@@ -2396,7 +2396,7 @@
           <p:cNvPr id="3" name="">
             <a:extLst xmlns:a="http://schemas.openxmlformats.org/drawingml/2006/main">
               <a:ext uri="{FF2B5EF4-FFF2-40B4-BE49-F238E27FC236}">
-                <a16:creationId xmlns:a16="http://schemas.microsoft.com/office/drawing/2014/main" id="{8A449164-B2A5-439D-BA89-50E3F2AB6752}"/>
+                <a16:creationId xmlns:a16="http://schemas.microsoft.com/office/drawing/2014/main" id="{BBF836F0-FB5F-4A7F-BC69-C6BB218EBB42}"/>
               </a:ext>
             </a:extLst>
           </p:cNvPr>
@@ -2477,7 +2477,7 @@
           <p:cNvPr id="4" name="">
             <a:extLst xmlns:a="http://schemas.openxmlformats.org/drawingml/2006/main">
               <a:ext uri="{FF2B5EF4-FFF2-40B4-BE49-F238E27FC236}">
-                <a16:creationId xmlns:a16="http://schemas.microsoft.com/office/drawing/2014/main" id="{EA325B4D-BEFF-41B2-B19C-5FD565261A60}"/>
+                <a16:creationId xmlns:a16="http://schemas.microsoft.com/office/drawing/2014/main" id="{0CC795F1-CD81-4ACA-9DE7-6F4CD1F5EA5F}"/>
               </a:ext>
             </a:extLst>
           </p:cNvPr>
@@ -2508,7 +2508,7 @@
           <p:cNvPr id="5" name="">
             <a:extLst xmlns:a="http://schemas.openxmlformats.org/drawingml/2006/main">
               <a:ext uri="{FF2B5EF4-FFF2-40B4-BE49-F238E27FC236}">
-                <a16:creationId xmlns:a16="http://schemas.microsoft.com/office/drawing/2014/main" id="{2FA042DD-8CD5-4C4E-A428-84188D884176}"/>
+                <a16:creationId xmlns:a16="http://schemas.microsoft.com/office/drawing/2014/main" id="{39EE670F-F15D-44E7-BE60-212EA1E21B8A}"/>
               </a:ext>
             </a:extLst>
           </p:cNvPr>
@@ -2566,7 +2566,7 @@
           <p:cNvPr id="6" name="">
             <a:extLst xmlns:a="http://schemas.openxmlformats.org/drawingml/2006/main">
               <a:ext uri="{FF2B5EF4-FFF2-40B4-BE49-F238E27FC236}">
-                <a16:creationId xmlns:a16="http://schemas.microsoft.com/office/drawing/2014/main" id="{67BC642D-0AD8-48E5-81ED-8443D4D60575}"/>
+                <a16:creationId xmlns:a16="http://schemas.microsoft.com/office/drawing/2014/main" id="{3D6E4821-8139-472B-A88D-2BC998BA5900}"/>
               </a:ext>
             </a:extLst>
           </p:cNvPr>
@@ -2624,7 +2624,7 @@
           <p:cNvPr id="7" name="">
             <a:extLst xmlns:a="http://schemas.openxmlformats.org/drawingml/2006/main">
               <a:ext uri="{FF2B5EF4-FFF2-40B4-BE49-F238E27FC236}">
-                <a16:creationId xmlns:a16="http://schemas.microsoft.com/office/drawing/2014/main" id="{FF80CF41-639A-4424-BFA9-95CA05CFB56E}"/>
+                <a16:creationId xmlns:a16="http://schemas.microsoft.com/office/drawing/2014/main" id="{C0EEBA61-B6F0-41E1-AE98-2FDB37DAA6BB}"/>
               </a:ext>
             </a:extLst>
           </p:cNvPr>
@@ -2655,7 +2655,7 @@
           <p:cNvPr id="8" name="">
             <a:extLst xmlns:a="http://schemas.openxmlformats.org/drawingml/2006/main">
               <a:ext uri="{FF2B5EF4-FFF2-40B4-BE49-F238E27FC236}">
-                <a16:creationId xmlns:a16="http://schemas.microsoft.com/office/drawing/2014/main" id="{9FDE6F50-2EA5-4BA2-BF82-B6873ED8A84D}"/>
+                <a16:creationId xmlns:a16="http://schemas.microsoft.com/office/drawing/2014/main" id="{5076C790-80CB-4F3A-91B3-7690CDA7F4AC}"/>
               </a:ext>
             </a:extLst>
           </p:cNvPr>
@@ -2759,7 +2759,7 @@
           <p:cNvPr id="9" name="">
             <a:extLst xmlns:a="http://schemas.openxmlformats.org/drawingml/2006/main">
               <a:ext uri="{FF2B5EF4-FFF2-40B4-BE49-F238E27FC236}">
-                <a16:creationId xmlns:a16="http://schemas.microsoft.com/office/drawing/2014/main" id="{39FE1432-75CC-4659-BFA8-0E13BB9372D6}"/>
+                <a16:creationId xmlns:a16="http://schemas.microsoft.com/office/drawing/2014/main" id="{E0900B97-A365-42A2-B9A1-E860DB317D14}"/>
               </a:ext>
             </a:extLst>
           </p:cNvPr>
@@ -2807,7 +2807,7 @@
                 <a:ea typeface="Helvetica Neue"/>
                 <a:cs typeface="Helvetica Neue"/>
               </a:rPr>
-              <a:t>Quiz: tinyurl.com/[add-after-form]</a:t>
+              <a:t>Quiz: tinyurl.com/cogs100-group8-quiz</a:t>
             </a:r>
           </a:p>
         </p:txBody>
@@ -2817,7 +2817,7 @@
           <p:cNvPr id="10" name="">
             <a:extLst xmlns:a="http://schemas.openxmlformats.org/drawingml/2006/main">
               <a:ext uri="{FF2B5EF4-FFF2-40B4-BE49-F238E27FC236}">
-                <a16:creationId xmlns:a16="http://schemas.microsoft.com/office/drawing/2014/main" id="{C2EB1A96-E296-499E-865A-F912A5673BF4}"/>
+                <a16:creationId xmlns:a16="http://schemas.microsoft.com/office/drawing/2014/main" id="{EFDF2CAA-DFC5-4B4C-B47A-4ED1B8767657}"/>
               </a:ext>
             </a:extLst>
           </p:cNvPr>
@@ -2873,7 +2873,7 @@
     </p:spTree>
     <p:extLst>
       <p:ext uri="{BB962C8B-B14F-4D97-AF65-F5344CB8AC3E}">
-        <p14:creationId xmlns:p14="http://schemas.microsoft.com/office/powerpoint/2010/main" val="1314302645"/>
+        <p14:creationId xmlns:p14="http://schemas.microsoft.com/office/powerpoint/2010/main" val="740072311"/>
       </p:ext>
     </p:extLst>
   </p:cSld>
@@ -2904,7 +2904,7 @@
           <p:cNvPr id="15" name="">
             <a:extLst xmlns:a="http://schemas.openxmlformats.org/drawingml/2006/main">
               <a:ext uri="{FF2B5EF4-FFF2-40B4-BE49-F238E27FC236}">
-                <a16:creationId xmlns:a16="http://schemas.microsoft.com/office/drawing/2014/main" id="{50DDDF31-8BA6-4E4E-9790-59E4763DD79D}"/>
+                <a16:creationId xmlns:a16="http://schemas.microsoft.com/office/drawing/2014/main" id="{C2A44FF0-3BC8-4155-8A87-9327A8F8552E}"/>
               </a:ext>
             </a:extLst>
           </p:cNvPr>
@@ -2962,7 +2962,7 @@
           <p:cNvPr id="2" name="">
             <a:extLst xmlns:a="http://schemas.openxmlformats.org/drawingml/2006/main">
               <a:ext uri="{FF2B5EF4-FFF2-40B4-BE49-F238E27FC236}">
-                <a16:creationId xmlns:a16="http://schemas.microsoft.com/office/drawing/2014/main" id="{B58D6E2A-45F6-4383-B121-2A1E105236F3}"/>
+                <a16:creationId xmlns:a16="http://schemas.microsoft.com/office/drawing/2014/main" id="{5FA19AAC-4904-44A6-8A67-A987DE3B4646}"/>
               </a:ext>
             </a:extLst>
           </p:cNvPr>
@@ -3020,7 +3020,7 @@
           <p:cNvPr id="3" name="">
             <a:extLst xmlns:a="http://schemas.openxmlformats.org/drawingml/2006/main">
               <a:ext uri="{FF2B5EF4-FFF2-40B4-BE49-F238E27FC236}">
-                <a16:creationId xmlns:a16="http://schemas.microsoft.com/office/drawing/2014/main" id="{8D0F074F-AAEB-4FFA-8EBB-158CA42C0948}"/>
+                <a16:creationId xmlns:a16="http://schemas.microsoft.com/office/drawing/2014/main" id="{B4A72E5A-DDC9-4C94-8EEA-14E4638FACFF}"/>
               </a:ext>
             </a:extLst>
           </p:cNvPr>
@@ -3051,7 +3051,7 @@
           <p:cNvPr id="4" name="">
             <a:extLst xmlns:a="http://schemas.openxmlformats.org/drawingml/2006/main">
               <a:ext uri="{FF2B5EF4-FFF2-40B4-BE49-F238E27FC236}">
-                <a16:creationId xmlns:a16="http://schemas.microsoft.com/office/drawing/2014/main" id="{9BB67804-801B-4264-8E7D-FD56F511FD2C}"/>
+                <a16:creationId xmlns:a16="http://schemas.microsoft.com/office/drawing/2014/main" id="{0A3D60F1-1AF9-4F70-A7A8-E4DF9FA7A737}"/>
               </a:ext>
             </a:extLst>
           </p:cNvPr>
@@ -3109,7 +3109,7 @@
           <p:cNvPr id="5" name="">
             <a:extLst xmlns:a="http://schemas.openxmlformats.org/drawingml/2006/main">
               <a:ext uri="{FF2B5EF4-FFF2-40B4-BE49-F238E27FC236}">
-                <a16:creationId xmlns:a16="http://schemas.microsoft.com/office/drawing/2014/main" id="{177787A4-5A50-4613-85D3-4811EE6C28A1}"/>
+                <a16:creationId xmlns:a16="http://schemas.microsoft.com/office/drawing/2014/main" id="{74FFA446-2BA1-4405-BEF6-F3A73E13F879}"/>
               </a:ext>
             </a:extLst>
           </p:cNvPr>
@@ -3167,7 +3167,7 @@
           <p:cNvPr id="6" name="">
             <a:extLst xmlns:a="http://schemas.openxmlformats.org/drawingml/2006/main">
               <a:ext uri="{FF2B5EF4-FFF2-40B4-BE49-F238E27FC236}">
-                <a16:creationId xmlns:a16="http://schemas.microsoft.com/office/drawing/2014/main" id="{FD78A9C7-4F00-4372-BA47-57C4DA576B67}"/>
+                <a16:creationId xmlns:a16="http://schemas.microsoft.com/office/drawing/2014/main" id="{B3ABD91E-BE97-48F7-BA72-3EA869431821}"/>
               </a:ext>
             </a:extLst>
           </p:cNvPr>
@@ -3271,7 +3271,7 @@
           <p:cNvPr id="7" name="">
             <a:extLst xmlns:a="http://schemas.openxmlformats.org/drawingml/2006/main">
               <a:ext uri="{FF2B5EF4-FFF2-40B4-BE49-F238E27FC236}">
-                <a16:creationId xmlns:a16="http://schemas.microsoft.com/office/drawing/2014/main" id="{829E92A4-790B-4DAF-824C-CEAEB658C4FC}"/>
+                <a16:creationId xmlns:a16="http://schemas.microsoft.com/office/drawing/2014/main" id="{D6A6EFCA-6525-44DA-9422-F629F8B59764}"/>
               </a:ext>
             </a:extLst>
           </p:cNvPr>
@@ -3302,7 +3302,7 @@
           <p:cNvPr id="8" name="">
             <a:extLst xmlns:a="http://schemas.openxmlformats.org/drawingml/2006/main">
               <a:ext uri="{FF2B5EF4-FFF2-40B4-BE49-F238E27FC236}">
-                <a16:creationId xmlns:a16="http://schemas.microsoft.com/office/drawing/2014/main" id="{15301182-B4E7-47B5-965F-CBF9D6D1D13F}"/>
+                <a16:creationId xmlns:a16="http://schemas.microsoft.com/office/drawing/2014/main" id="{D03E6E20-50CC-42BB-9390-D40A8DDB64B1}"/>
               </a:ext>
             </a:extLst>
           </p:cNvPr>
@@ -3360,7 +3360,7 @@
           <p:cNvPr id="9" name="">
             <a:extLst xmlns:a="http://schemas.openxmlformats.org/drawingml/2006/main">
               <a:ext uri="{FF2B5EF4-FFF2-40B4-BE49-F238E27FC236}">
-                <a16:creationId xmlns:a16="http://schemas.microsoft.com/office/drawing/2014/main" id="{9C8C48DB-5998-4260-B773-4A3119202A3E}"/>
+                <a16:creationId xmlns:a16="http://schemas.microsoft.com/office/drawing/2014/main" id="{0BEB168F-070A-4655-8791-FBBD4A200C35}"/>
               </a:ext>
             </a:extLst>
           </p:cNvPr>
@@ -3418,7 +3418,7 @@
           <p:cNvPr id="10" name="">
             <a:extLst xmlns:a="http://schemas.openxmlformats.org/drawingml/2006/main">
               <a:ext uri="{FF2B5EF4-FFF2-40B4-BE49-F238E27FC236}">
-                <a16:creationId xmlns:a16="http://schemas.microsoft.com/office/drawing/2014/main" id="{F1E89A0D-E537-4432-A8C6-7620696409E4}"/>
+                <a16:creationId xmlns:a16="http://schemas.microsoft.com/office/drawing/2014/main" id="{240AF38B-9AC8-49F6-A0EA-320B98ECD5C9}"/>
               </a:ext>
             </a:extLst>
           </p:cNvPr>
@@ -3522,7 +3522,7 @@
           <p:cNvPr id="11" name="">
             <a:extLst xmlns:a="http://schemas.openxmlformats.org/drawingml/2006/main">
               <a:ext uri="{FF2B5EF4-FFF2-40B4-BE49-F238E27FC236}">
-                <a16:creationId xmlns:a16="http://schemas.microsoft.com/office/drawing/2014/main" id="{FD23906E-5EA2-4FCF-87A4-4452CF294BCC}"/>
+                <a16:creationId xmlns:a16="http://schemas.microsoft.com/office/drawing/2014/main" id="{949C3E11-3FED-4752-A750-C6037E63B00B}"/>
               </a:ext>
             </a:extLst>
           </p:cNvPr>
@@ -3580,7 +3580,7 @@
           <p:cNvPr id="12" name="">
             <a:extLst xmlns:a="http://schemas.openxmlformats.org/drawingml/2006/main">
               <a:ext uri="{FF2B5EF4-FFF2-40B4-BE49-F238E27FC236}">
-                <a16:creationId xmlns:a16="http://schemas.microsoft.com/office/drawing/2014/main" id="{10B29AD4-57A7-4585-B347-F2AB33B6248D}"/>
+                <a16:creationId xmlns:a16="http://schemas.microsoft.com/office/drawing/2014/main" id="{0F13E918-970C-4BC9-8105-81AB1164A96C}"/>
               </a:ext>
             </a:extLst>
           </p:cNvPr>
@@ -3611,7 +3611,7 @@
           <p:cNvPr id="13" name="">
             <a:extLst xmlns:a="http://schemas.openxmlformats.org/drawingml/2006/main">
               <a:ext uri="{FF2B5EF4-FFF2-40B4-BE49-F238E27FC236}">
-                <a16:creationId xmlns:a16="http://schemas.microsoft.com/office/drawing/2014/main" id="{846B7701-0E55-4394-9EF7-788B53E63A88}"/>
+                <a16:creationId xmlns:a16="http://schemas.microsoft.com/office/drawing/2014/main" id="{A6900AF3-C3D6-4E4F-AF38-FEDA3B19CF22}"/>
               </a:ext>
             </a:extLst>
           </p:cNvPr>
@@ -3669,7 +3669,7 @@
           <p:cNvPr id="14" name="">
             <a:extLst xmlns:a="http://schemas.openxmlformats.org/drawingml/2006/main">
               <a:ext uri="{FF2B5EF4-FFF2-40B4-BE49-F238E27FC236}">
-                <a16:creationId xmlns:a16="http://schemas.microsoft.com/office/drawing/2014/main" id="{03874AED-0ADD-4137-B288-932B2BE16C3D}"/>
+                <a16:creationId xmlns:a16="http://schemas.microsoft.com/office/drawing/2014/main" id="{A5EF37EE-C7FE-450A-88FE-93CEC07324FA}"/>
               </a:ext>
             </a:extLst>
           </p:cNvPr>
@@ -3725,7 +3725,7 @@
     </p:spTree>
     <p:extLst>
       <p:ext uri="{BB962C8B-B14F-4D97-AF65-F5344CB8AC3E}">
-        <p14:creationId xmlns:p14="http://schemas.microsoft.com/office/powerpoint/2010/main" val="918770732"/>
+        <p14:creationId xmlns:p14="http://schemas.microsoft.com/office/powerpoint/2010/main" val="1056164906"/>
       </p:ext>
     </p:extLst>
   </p:cSld>
@@ -3756,7 +3756,7 @@
           <p:cNvPr id="15" name="">
             <a:extLst xmlns:a="http://schemas.openxmlformats.org/drawingml/2006/main">
               <a:ext uri="{FF2B5EF4-FFF2-40B4-BE49-F238E27FC236}">
-                <a16:creationId xmlns:a16="http://schemas.microsoft.com/office/drawing/2014/main" id="{90FACFF4-A7F9-4421-A35C-05A47C79B7F6}"/>
+                <a16:creationId xmlns:a16="http://schemas.microsoft.com/office/drawing/2014/main" id="{5E32B59F-674A-486F-A7A0-396E78154BA7}"/>
               </a:ext>
             </a:extLst>
           </p:cNvPr>
@@ -3814,7 +3814,7 @@
           <p:cNvPr id="2" name="">
             <a:extLst xmlns:a="http://schemas.openxmlformats.org/drawingml/2006/main">
               <a:ext uri="{FF2B5EF4-FFF2-40B4-BE49-F238E27FC236}">
-                <a16:creationId xmlns:a16="http://schemas.microsoft.com/office/drawing/2014/main" id="{BE71DF0B-8212-4035-B941-BD84990E08AF}"/>
+                <a16:creationId xmlns:a16="http://schemas.microsoft.com/office/drawing/2014/main" id="{BE4A5F20-4372-4D5B-8DAA-D4998625E73E}"/>
               </a:ext>
             </a:extLst>
           </p:cNvPr>
@@ -3872,7 +3872,7 @@
           <p:cNvPr id="3" name="">
             <a:extLst xmlns:a="http://schemas.openxmlformats.org/drawingml/2006/main">
               <a:ext uri="{FF2B5EF4-FFF2-40B4-BE49-F238E27FC236}">
-                <a16:creationId xmlns:a16="http://schemas.microsoft.com/office/drawing/2014/main" id="{67540F47-B094-44E7-A508-B28E2D560A0E}"/>
+                <a16:creationId xmlns:a16="http://schemas.microsoft.com/office/drawing/2014/main" id="{D6476A8A-95C2-4C84-9BA6-CF5A72A80873}"/>
               </a:ext>
             </a:extLst>
           </p:cNvPr>
@@ -3903,7 +3903,7 @@
           <p:cNvPr id="4" name="">
             <a:extLst xmlns:a="http://schemas.openxmlformats.org/drawingml/2006/main">
               <a:ext uri="{FF2B5EF4-FFF2-40B4-BE49-F238E27FC236}">
-                <a16:creationId xmlns:a16="http://schemas.microsoft.com/office/drawing/2014/main" id="{A615AA9A-A69C-4473-8609-0E1389568986}"/>
+                <a16:creationId xmlns:a16="http://schemas.microsoft.com/office/drawing/2014/main" id="{0D71A873-D803-4CED-AABB-452DCFE0CC9C}"/>
               </a:ext>
             </a:extLst>
           </p:cNvPr>
@@ -3961,7 +3961,7 @@
           <p:cNvPr id="5" name="">
             <a:extLst xmlns:a="http://schemas.openxmlformats.org/drawingml/2006/main">
               <a:ext uri="{FF2B5EF4-FFF2-40B4-BE49-F238E27FC236}">
-                <a16:creationId xmlns:a16="http://schemas.microsoft.com/office/drawing/2014/main" id="{E0B351B8-25E7-45E2-9676-BB03CA024AE2}"/>
+                <a16:creationId xmlns:a16="http://schemas.microsoft.com/office/drawing/2014/main" id="{3E8F1A82-7832-440A-B104-7FD4CC615221}"/>
               </a:ext>
             </a:extLst>
           </p:cNvPr>
@@ -4019,7 +4019,7 @@
           <p:cNvPr id="6" name="">
             <a:extLst xmlns:a="http://schemas.openxmlformats.org/drawingml/2006/main">
               <a:ext uri="{FF2B5EF4-FFF2-40B4-BE49-F238E27FC236}">
-                <a16:creationId xmlns:a16="http://schemas.microsoft.com/office/drawing/2014/main" id="{3A0F2D1A-3B5D-46AF-BFCA-9AB10F044602}"/>
+                <a16:creationId xmlns:a16="http://schemas.microsoft.com/office/drawing/2014/main" id="{BF063982-3D5E-4A36-BEEA-18B04C3264A9}"/>
               </a:ext>
             </a:extLst>
           </p:cNvPr>
@@ -4077,7 +4077,7 @@
           <p:cNvPr id="7" name="">
             <a:extLst xmlns:a="http://schemas.openxmlformats.org/drawingml/2006/main">
               <a:ext uri="{FF2B5EF4-FFF2-40B4-BE49-F238E27FC236}">
-                <a16:creationId xmlns:a16="http://schemas.microsoft.com/office/drawing/2014/main" id="{A8433FEE-6FFB-49C9-B77B-BC7606BF0480}"/>
+                <a16:creationId xmlns:a16="http://schemas.microsoft.com/office/drawing/2014/main" id="{FA84E1CB-5C1F-4E96-8E42-DFB03B779FD3}"/>
               </a:ext>
             </a:extLst>
           </p:cNvPr>
@@ -4108,7 +4108,7 @@
           <p:cNvPr id="8" name="">
             <a:extLst xmlns:a="http://schemas.openxmlformats.org/drawingml/2006/main">
               <a:ext uri="{FF2B5EF4-FFF2-40B4-BE49-F238E27FC236}">
-                <a16:creationId xmlns:a16="http://schemas.microsoft.com/office/drawing/2014/main" id="{7F63734E-1F23-45A3-AB0E-7EC7DEA0074B}"/>
+                <a16:creationId xmlns:a16="http://schemas.microsoft.com/office/drawing/2014/main" id="{16AFAADC-E1E5-405D-8194-E5C620F77B9E}"/>
               </a:ext>
             </a:extLst>
           </p:cNvPr>
@@ -4166,7 +4166,7 @@
           <p:cNvPr id="9" name="">
             <a:extLst xmlns:a="http://schemas.openxmlformats.org/drawingml/2006/main">
               <a:ext uri="{FF2B5EF4-FFF2-40B4-BE49-F238E27FC236}">
-                <a16:creationId xmlns:a16="http://schemas.microsoft.com/office/drawing/2014/main" id="{3F959136-EC3E-4DC1-A458-1DDCD2269649}"/>
+                <a16:creationId xmlns:a16="http://schemas.microsoft.com/office/drawing/2014/main" id="{443945E3-03D3-4B4E-A94F-47250D957C35}"/>
               </a:ext>
             </a:extLst>
           </p:cNvPr>
@@ -4224,7 +4224,7 @@
           <p:cNvPr id="10" name="">
             <a:extLst xmlns:a="http://schemas.openxmlformats.org/drawingml/2006/main">
               <a:ext uri="{FF2B5EF4-FFF2-40B4-BE49-F238E27FC236}">
-                <a16:creationId xmlns:a16="http://schemas.microsoft.com/office/drawing/2014/main" id="{AA04A68F-40EC-4F11-A25E-569A0408A731}"/>
+                <a16:creationId xmlns:a16="http://schemas.microsoft.com/office/drawing/2014/main" id="{DC7729B3-4B5C-4E3A-A1AA-F37E6B3C3E73}"/>
               </a:ext>
             </a:extLst>
           </p:cNvPr>
@@ -4282,7 +4282,7 @@
           <p:cNvPr id="11" name="">
             <a:extLst xmlns:a="http://schemas.openxmlformats.org/drawingml/2006/main">
               <a:ext uri="{FF2B5EF4-FFF2-40B4-BE49-F238E27FC236}">
-                <a16:creationId xmlns:a16="http://schemas.microsoft.com/office/drawing/2014/main" id="{A0FF3AC2-6C77-4022-AD9C-C5A75A2FEA3A}"/>
+                <a16:creationId xmlns:a16="http://schemas.microsoft.com/office/drawing/2014/main" id="{4B51B992-7B6A-46DF-922E-56FD44F72F5A}"/>
               </a:ext>
             </a:extLst>
           </p:cNvPr>
@@ -4340,7 +4340,7 @@
           <p:cNvPr id="12" name="">
             <a:extLst xmlns:a="http://schemas.openxmlformats.org/drawingml/2006/main">
               <a:ext uri="{FF2B5EF4-FFF2-40B4-BE49-F238E27FC236}">
-                <a16:creationId xmlns:a16="http://schemas.microsoft.com/office/drawing/2014/main" id="{F0E48415-0609-407C-8D78-91E0D8542FAA}"/>
+                <a16:creationId xmlns:a16="http://schemas.microsoft.com/office/drawing/2014/main" id="{74A5FAF4-1C4F-4CC2-ABE4-EE6580785615}"/>
               </a:ext>
             </a:extLst>
           </p:cNvPr>
@@ -4371,7 +4371,7 @@
           <p:cNvPr id="13" name="">
             <a:extLst xmlns:a="http://schemas.openxmlformats.org/drawingml/2006/main">
               <a:ext uri="{FF2B5EF4-FFF2-40B4-BE49-F238E27FC236}">
-                <a16:creationId xmlns:a16="http://schemas.microsoft.com/office/drawing/2014/main" id="{F22D31D3-31CD-49F4-854B-98DFD7CE7911}"/>
+                <a16:creationId xmlns:a16="http://schemas.microsoft.com/office/drawing/2014/main" id="{7A777F6D-7FE4-4082-BF78-454BFC30E3B7}"/>
               </a:ext>
             </a:extLst>
           </p:cNvPr>
@@ -4429,7 +4429,7 @@
           <p:cNvPr id="14" name="">
             <a:extLst xmlns:a="http://schemas.openxmlformats.org/drawingml/2006/main">
               <a:ext uri="{FF2B5EF4-FFF2-40B4-BE49-F238E27FC236}">
-                <a16:creationId xmlns:a16="http://schemas.microsoft.com/office/drawing/2014/main" id="{E1873CD2-8217-4176-B05E-2A20CE047106}"/>
+                <a16:creationId xmlns:a16="http://schemas.microsoft.com/office/drawing/2014/main" id="{5A4FF825-6D8E-4473-AE22-645658DDECF4}"/>
               </a:ext>
             </a:extLst>
           </p:cNvPr>
@@ -4485,7 +4485,7 @@
     </p:spTree>
     <p:extLst>
       <p:ext uri="{BB962C8B-B14F-4D97-AF65-F5344CB8AC3E}">
-        <p14:creationId xmlns:p14="http://schemas.microsoft.com/office/powerpoint/2010/main" val="1493891621"/>
+        <p14:creationId xmlns:p14="http://schemas.microsoft.com/office/powerpoint/2010/main" val="1027099316"/>
       </p:ext>
     </p:extLst>
   </p:cSld>
@@ -4516,7 +4516,7 @@
           <p:cNvPr id="14" name="">
             <a:extLst xmlns:a="http://schemas.openxmlformats.org/drawingml/2006/main">
               <a:ext uri="{FF2B5EF4-FFF2-40B4-BE49-F238E27FC236}">
-                <a16:creationId xmlns:a16="http://schemas.microsoft.com/office/drawing/2014/main" id="{B6CA9977-F739-4AA1-81A2-E8AF25BF6518}"/>
+                <a16:creationId xmlns:a16="http://schemas.microsoft.com/office/drawing/2014/main" id="{4FEE0909-25C6-4D36-9B8B-00A59CB1F062}"/>
               </a:ext>
             </a:extLst>
           </p:cNvPr>
@@ -4574,7 +4574,7 @@
           <p:cNvPr id="2" name="">
             <a:extLst xmlns:a="http://schemas.openxmlformats.org/drawingml/2006/main">
               <a:ext uri="{FF2B5EF4-FFF2-40B4-BE49-F238E27FC236}">
-                <a16:creationId xmlns:a16="http://schemas.microsoft.com/office/drawing/2014/main" id="{9690C593-2A86-463C-A56E-35B2C8B1B322}"/>
+                <a16:creationId xmlns:a16="http://schemas.microsoft.com/office/drawing/2014/main" id="{8E368BFA-68E0-4163-861E-5C7DD385C3E8}"/>
               </a:ext>
             </a:extLst>
           </p:cNvPr>
@@ -4655,7 +4655,7 @@
           <p:cNvPr id="3" name="">
             <a:extLst xmlns:a="http://schemas.openxmlformats.org/drawingml/2006/main">
               <a:ext uri="{FF2B5EF4-FFF2-40B4-BE49-F238E27FC236}">
-                <a16:creationId xmlns:a16="http://schemas.microsoft.com/office/drawing/2014/main" id="{823D3925-D573-4849-9BDC-25D949F2EB07}"/>
+                <a16:creationId xmlns:a16="http://schemas.microsoft.com/office/drawing/2014/main" id="{9DB8ED56-806C-404B-8BB3-107294A4D99F}"/>
               </a:ext>
             </a:extLst>
           </p:cNvPr>
@@ -4686,7 +4686,7 @@
           <p:cNvPr id="4" name="">
             <a:extLst xmlns:a="http://schemas.openxmlformats.org/drawingml/2006/main">
               <a:ext uri="{FF2B5EF4-FFF2-40B4-BE49-F238E27FC236}">
-                <a16:creationId xmlns:a16="http://schemas.microsoft.com/office/drawing/2014/main" id="{8870CA19-D8B8-4BEE-93FA-EB98D0723823}"/>
+                <a16:creationId xmlns:a16="http://schemas.microsoft.com/office/drawing/2014/main" id="{C6F9A4B6-1B77-4972-93A4-027F0ECD8D8D}"/>
               </a:ext>
             </a:extLst>
           </p:cNvPr>
@@ -4744,7 +4744,7 @@
           <p:cNvPr id="5" name="">
             <a:extLst xmlns:a="http://schemas.openxmlformats.org/drawingml/2006/main">
               <a:ext uri="{FF2B5EF4-FFF2-40B4-BE49-F238E27FC236}">
-                <a16:creationId xmlns:a16="http://schemas.microsoft.com/office/drawing/2014/main" id="{644BF156-5431-4573-8B43-18B405BF0269}"/>
+                <a16:creationId xmlns:a16="http://schemas.microsoft.com/office/drawing/2014/main" id="{A36BCC04-AA47-493F-912D-8A0552201694}"/>
               </a:ext>
             </a:extLst>
           </p:cNvPr>
@@ -4802,7 +4802,7 @@
           <p:cNvPr id="6" name="">
             <a:extLst xmlns:a="http://schemas.openxmlformats.org/drawingml/2006/main">
               <a:ext uri="{FF2B5EF4-FFF2-40B4-BE49-F238E27FC236}">
-                <a16:creationId xmlns:a16="http://schemas.microsoft.com/office/drawing/2014/main" id="{FB89C655-DC2C-4A2E-9421-5B4E6559B5A4}"/>
+                <a16:creationId xmlns:a16="http://schemas.microsoft.com/office/drawing/2014/main" id="{66335887-ED03-4F3A-B260-70D837ECD8F7}"/>
               </a:ext>
             </a:extLst>
           </p:cNvPr>
@@ -4860,7 +4860,7 @@
           <p:cNvPr id="7" name="">
             <a:extLst xmlns:a="http://schemas.openxmlformats.org/drawingml/2006/main">
               <a:ext uri="{FF2B5EF4-FFF2-40B4-BE49-F238E27FC236}">
-                <a16:creationId xmlns:a16="http://schemas.microsoft.com/office/drawing/2014/main" id="{3679866B-457D-4985-B8E3-BE6BBC604035}"/>
+                <a16:creationId xmlns:a16="http://schemas.microsoft.com/office/drawing/2014/main" id="{6BA8D71A-1899-4CF1-9F2F-1022EA16BBF0}"/>
               </a:ext>
             </a:extLst>
           </p:cNvPr>
@@ -4918,7 +4918,7 @@
           <p:cNvPr id="8" name="">
             <a:extLst xmlns:a="http://schemas.openxmlformats.org/drawingml/2006/main">
               <a:ext uri="{FF2B5EF4-FFF2-40B4-BE49-F238E27FC236}">
-                <a16:creationId xmlns:a16="http://schemas.microsoft.com/office/drawing/2014/main" id="{95AE578A-D462-42FE-8FD4-C684A2E4FD04}"/>
+                <a16:creationId xmlns:a16="http://schemas.microsoft.com/office/drawing/2014/main" id="{3F9B8D42-C4E4-4819-A3A0-65E9EAC583F7}"/>
               </a:ext>
             </a:extLst>
           </p:cNvPr>
@@ -4976,7 +4976,7 @@
           <p:cNvPr id="9" name="">
             <a:extLst xmlns:a="http://schemas.openxmlformats.org/drawingml/2006/main">
               <a:ext uri="{FF2B5EF4-FFF2-40B4-BE49-F238E27FC236}">
-                <a16:creationId xmlns:a16="http://schemas.microsoft.com/office/drawing/2014/main" id="{48686B15-7397-4149-930D-4EDBCE9CA83D}"/>
+                <a16:creationId xmlns:a16="http://schemas.microsoft.com/office/drawing/2014/main" id="{4A767A14-0175-439D-9E88-8D6F724B5841}"/>
               </a:ext>
             </a:extLst>
           </p:cNvPr>
@@ -5034,7 +5034,7 @@
           <p:cNvPr id="10" name="">
             <a:extLst xmlns:a="http://schemas.openxmlformats.org/drawingml/2006/main">
               <a:ext uri="{FF2B5EF4-FFF2-40B4-BE49-F238E27FC236}">
-                <a16:creationId xmlns:a16="http://schemas.microsoft.com/office/drawing/2014/main" id="{5EFA17A4-6380-4035-8258-0F54BA9A48B4}"/>
+                <a16:creationId xmlns:a16="http://schemas.microsoft.com/office/drawing/2014/main" id="{53CF2142-5B1F-4F49-9452-788D868F4D12}"/>
               </a:ext>
             </a:extLst>
           </p:cNvPr>
@@ -5082,7 +5082,7 @@
                 <a:ea typeface="Helvetica Neue"/>
                 <a:cs typeface="Helvetica Neue"/>
               </a:rPr>
-              <a:t>Quiz link: tinyurl.com/[add-after-form]</a:t>
+              <a:t>Quiz link: tinyurl.com/cogs100-group8-quiz</a:t>
             </a:r>
           </a:p>
         </p:txBody>
@@ -5092,7 +5092,7 @@
           <p:cNvPr id="11" name="">
             <a:extLst xmlns:a="http://schemas.openxmlformats.org/drawingml/2006/main">
               <a:ext uri="{FF2B5EF4-FFF2-40B4-BE49-F238E27FC236}">
-                <a16:creationId xmlns:a16="http://schemas.microsoft.com/office/drawing/2014/main" id="{0FE28847-2FE2-4C95-BF64-030E0E4FA999}"/>
+                <a16:creationId xmlns:a16="http://schemas.microsoft.com/office/drawing/2014/main" id="{B943801D-4982-4901-9158-8F12F535401C}"/>
               </a:ext>
             </a:extLst>
           </p:cNvPr>
@@ -5123,7 +5123,7 @@
           <p:cNvPr id="12" name="">
             <a:extLst xmlns:a="http://schemas.openxmlformats.org/drawingml/2006/main">
               <a:ext uri="{FF2B5EF4-FFF2-40B4-BE49-F238E27FC236}">
-                <a16:creationId xmlns:a16="http://schemas.microsoft.com/office/drawing/2014/main" id="{8FF7728E-3F69-4DE7-AC63-81C821B919BF}"/>
+                <a16:creationId xmlns:a16="http://schemas.microsoft.com/office/drawing/2014/main" id="{65E617FA-B9ED-4461-B119-BB0AFD55E7CD}"/>
               </a:ext>
             </a:extLst>
           </p:cNvPr>
@@ -5181,7 +5181,7 @@
           <p:cNvPr id="13" name="">
             <a:extLst xmlns:a="http://schemas.openxmlformats.org/drawingml/2006/main">
               <a:ext uri="{FF2B5EF4-FFF2-40B4-BE49-F238E27FC236}">
-                <a16:creationId xmlns:a16="http://schemas.microsoft.com/office/drawing/2014/main" id="{276D9B46-4E8D-454D-9783-FC2F182FE554}"/>
+                <a16:creationId xmlns:a16="http://schemas.microsoft.com/office/drawing/2014/main" id="{045E813D-9AB4-4163-BE4E-80C8F800351C}"/>
               </a:ext>
             </a:extLst>
           </p:cNvPr>
@@ -5237,7 +5237,7 @@
     </p:spTree>
     <p:extLst>
       <p:ext uri="{BB962C8B-B14F-4D97-AF65-F5344CB8AC3E}">
-        <p14:creationId xmlns:p14="http://schemas.microsoft.com/office/powerpoint/2010/main" val="195695178"/>
+        <p14:creationId xmlns:p14="http://schemas.microsoft.com/office/powerpoint/2010/main" val="1989498125"/>
       </p:ext>
     </p:extLst>
   </p:cSld>
@@ -5268,7 +5268,7 @@
           <p:cNvPr id="15" name="">
             <a:extLst xmlns:a="http://schemas.openxmlformats.org/drawingml/2006/main">
               <a:ext uri="{FF2B5EF4-FFF2-40B4-BE49-F238E27FC236}">
-                <a16:creationId xmlns:a16="http://schemas.microsoft.com/office/drawing/2014/main" id="{9560009A-1929-43D9-9505-B84F31A30E85}"/>
+                <a16:creationId xmlns:a16="http://schemas.microsoft.com/office/drawing/2014/main" id="{7A9BECD4-5E2D-4658-A1AD-3FDBE440B0F1}"/>
               </a:ext>
             </a:extLst>
           </p:cNvPr>
@@ -5326,7 +5326,7 @@
           <p:cNvPr id="2" name="">
             <a:extLst xmlns:a="http://schemas.openxmlformats.org/drawingml/2006/main">
               <a:ext uri="{FF2B5EF4-FFF2-40B4-BE49-F238E27FC236}">
-                <a16:creationId xmlns:a16="http://schemas.microsoft.com/office/drawing/2014/main" id="{7CF1AD76-2842-4251-A1C5-81BA70CAC106}"/>
+                <a16:creationId xmlns:a16="http://schemas.microsoft.com/office/drawing/2014/main" id="{AE4BB69B-1DCA-4E04-89D7-700A2C87917C}"/>
               </a:ext>
             </a:extLst>
           </p:cNvPr>
@@ -5384,7 +5384,7 @@
           <p:cNvPr id="3" name="">
             <a:extLst xmlns:a="http://schemas.openxmlformats.org/drawingml/2006/main">
               <a:ext uri="{FF2B5EF4-FFF2-40B4-BE49-F238E27FC236}">
-                <a16:creationId xmlns:a16="http://schemas.microsoft.com/office/drawing/2014/main" id="{55F50C4E-B3F8-4D7E-BE45-A0AD94FB5A39}"/>
+                <a16:creationId xmlns:a16="http://schemas.microsoft.com/office/drawing/2014/main" id="{20C55CCB-8D3E-4989-A447-B72D857B6D59}"/>
               </a:ext>
             </a:extLst>
           </p:cNvPr>
@@ -5415,7 +5415,7 @@
           <p:cNvPr id="4" name="">
             <a:extLst xmlns:a="http://schemas.openxmlformats.org/drawingml/2006/main">
               <a:ext uri="{FF2B5EF4-FFF2-40B4-BE49-F238E27FC236}">
-                <a16:creationId xmlns:a16="http://schemas.microsoft.com/office/drawing/2014/main" id="{D4AD4BDE-9ED8-43FF-B8B2-B048FBC4F7CC}"/>
+                <a16:creationId xmlns:a16="http://schemas.microsoft.com/office/drawing/2014/main" id="{CDD460A6-62E6-4139-A897-659FB71759AA}"/>
               </a:ext>
             </a:extLst>
           </p:cNvPr>
@@ -5473,7 +5473,7 @@
           <p:cNvPr id="5" name="">
             <a:extLst xmlns:a="http://schemas.openxmlformats.org/drawingml/2006/main">
               <a:ext uri="{FF2B5EF4-FFF2-40B4-BE49-F238E27FC236}">
-                <a16:creationId xmlns:a16="http://schemas.microsoft.com/office/drawing/2014/main" id="{6C348D73-CD6D-489A-8E50-78D96ACE3EAF}"/>
+                <a16:creationId xmlns:a16="http://schemas.microsoft.com/office/drawing/2014/main" id="{E739BF60-1BF3-4C2A-B32A-28B569B4635C}"/>
               </a:ext>
             </a:extLst>
           </p:cNvPr>
@@ -5554,7 +5554,7 @@
           <p:cNvPr id="6" name="">
             <a:extLst xmlns:a="http://schemas.openxmlformats.org/drawingml/2006/main">
               <a:ext uri="{FF2B5EF4-FFF2-40B4-BE49-F238E27FC236}">
-                <a16:creationId xmlns:a16="http://schemas.microsoft.com/office/drawing/2014/main" id="{5C59C681-6800-4B1E-97A6-943E37F9BFB3}"/>
+                <a16:creationId xmlns:a16="http://schemas.microsoft.com/office/drawing/2014/main" id="{EBBE552C-2F56-4C50-B09B-53660A0C74B5}"/>
               </a:ext>
             </a:extLst>
           </p:cNvPr>
@@ -5612,7 +5612,7 @@
           <p:cNvPr id="7" name="">
             <a:extLst xmlns:a="http://schemas.openxmlformats.org/drawingml/2006/main">
               <a:ext uri="{FF2B5EF4-FFF2-40B4-BE49-F238E27FC236}">
-                <a16:creationId xmlns:a16="http://schemas.microsoft.com/office/drawing/2014/main" id="{59236FE6-4AFC-4B43-B2BE-784A49CA46B9}"/>
+                <a16:creationId xmlns:a16="http://schemas.microsoft.com/office/drawing/2014/main" id="{087FCA68-7552-4DB3-AE36-7C5B952F81CF}"/>
               </a:ext>
             </a:extLst>
           </p:cNvPr>
@@ -5643,7 +5643,7 @@
           <p:cNvPr id="8" name="">
             <a:extLst xmlns:a="http://schemas.openxmlformats.org/drawingml/2006/main">
               <a:ext uri="{FF2B5EF4-FFF2-40B4-BE49-F238E27FC236}">
-                <a16:creationId xmlns:a16="http://schemas.microsoft.com/office/drawing/2014/main" id="{F777AF19-2D0C-4D33-A49F-58A0BE25F453}"/>
+                <a16:creationId xmlns:a16="http://schemas.microsoft.com/office/drawing/2014/main" id="{ADE2E57C-E25A-4D66-8300-AA09DC8D94E9}"/>
               </a:ext>
             </a:extLst>
           </p:cNvPr>
@@ -5701,7 +5701,7 @@
           <p:cNvPr id="9" name="">
             <a:extLst xmlns:a="http://schemas.openxmlformats.org/drawingml/2006/main">
               <a:ext uri="{FF2B5EF4-FFF2-40B4-BE49-F238E27FC236}">
-                <a16:creationId xmlns:a16="http://schemas.microsoft.com/office/drawing/2014/main" id="{739E7713-E577-4133-B75F-758A8D4B51B9}"/>
+                <a16:creationId xmlns:a16="http://schemas.microsoft.com/office/drawing/2014/main" id="{0670DD45-387B-42BF-840F-CFE5AD5EE1D0}"/>
               </a:ext>
             </a:extLst>
           </p:cNvPr>
@@ -5782,7 +5782,7 @@
           <p:cNvPr id="10" name="">
             <a:extLst xmlns:a="http://schemas.openxmlformats.org/drawingml/2006/main">
               <a:ext uri="{FF2B5EF4-FFF2-40B4-BE49-F238E27FC236}">
-                <a16:creationId xmlns:a16="http://schemas.microsoft.com/office/drawing/2014/main" id="{CB41A062-57FF-48E7-B222-A20814FDB2F1}"/>
+                <a16:creationId xmlns:a16="http://schemas.microsoft.com/office/drawing/2014/main" id="{7BC03FEB-8593-4E89-B536-C9755F026E12}"/>
               </a:ext>
             </a:extLst>
           </p:cNvPr>
@@ -5840,7 +5840,7 @@
           <p:cNvPr id="11" name="">
             <a:extLst xmlns:a="http://schemas.openxmlformats.org/drawingml/2006/main">
               <a:ext uri="{FF2B5EF4-FFF2-40B4-BE49-F238E27FC236}">
-                <a16:creationId xmlns:a16="http://schemas.microsoft.com/office/drawing/2014/main" id="{BC8AAD73-174B-4DE3-BE2B-CF91E883AAC2}"/>
+                <a16:creationId xmlns:a16="http://schemas.microsoft.com/office/drawing/2014/main" id="{80ED7ED4-17A9-494D-A9CB-ADD2500C20D4}"/>
               </a:ext>
             </a:extLst>
           </p:cNvPr>
@@ -5898,7 +5898,7 @@
           <p:cNvPr id="12" name="">
             <a:extLst xmlns:a="http://schemas.openxmlformats.org/drawingml/2006/main">
               <a:ext uri="{FF2B5EF4-FFF2-40B4-BE49-F238E27FC236}">
-                <a16:creationId xmlns:a16="http://schemas.microsoft.com/office/drawing/2014/main" id="{F6AF105F-2D58-4B22-8D39-6F3CE49FD676}"/>
+                <a16:creationId xmlns:a16="http://schemas.microsoft.com/office/drawing/2014/main" id="{CEF43E29-044A-4CA1-84E0-7BAE81860181}"/>
               </a:ext>
             </a:extLst>
           </p:cNvPr>
@@ -5929,7 +5929,7 @@
           <p:cNvPr id="13" name="">
             <a:extLst xmlns:a="http://schemas.openxmlformats.org/drawingml/2006/main">
               <a:ext uri="{FF2B5EF4-FFF2-40B4-BE49-F238E27FC236}">
-                <a16:creationId xmlns:a16="http://schemas.microsoft.com/office/drawing/2014/main" id="{AFCC842E-E2C4-4EF2-AAEC-852E4038DC62}"/>
+                <a16:creationId xmlns:a16="http://schemas.microsoft.com/office/drawing/2014/main" id="{6C18B38C-A550-4337-A826-CBB24177E1C4}"/>
               </a:ext>
             </a:extLst>
           </p:cNvPr>
@@ -5987,7 +5987,7 @@
           <p:cNvPr id="14" name="">
             <a:extLst xmlns:a="http://schemas.openxmlformats.org/drawingml/2006/main">
               <a:ext uri="{FF2B5EF4-FFF2-40B4-BE49-F238E27FC236}">
-                <a16:creationId xmlns:a16="http://schemas.microsoft.com/office/drawing/2014/main" id="{60A74684-951C-4C06-92F3-FBDF9C591963}"/>
+                <a16:creationId xmlns:a16="http://schemas.microsoft.com/office/drawing/2014/main" id="{0C1DAAB0-D7B7-4EC3-9A14-BA859729F6E3}"/>
               </a:ext>
             </a:extLst>
           </p:cNvPr>
@@ -6043,7 +6043,7 @@
     </p:spTree>
     <p:extLst>
       <p:ext uri="{BB962C8B-B14F-4D97-AF65-F5344CB8AC3E}">
-        <p14:creationId xmlns:p14="http://schemas.microsoft.com/office/powerpoint/2010/main" val="622085957"/>
+        <p14:creationId xmlns:p14="http://schemas.microsoft.com/office/powerpoint/2010/main" val="106021205"/>
       </p:ext>
     </p:extLst>
   </p:cSld>
@@ -6074,7 +6074,7 @@
           <p:cNvPr id="16" name="">
             <a:extLst xmlns:a="http://schemas.openxmlformats.org/drawingml/2006/main">
               <a:ext uri="{FF2B5EF4-FFF2-40B4-BE49-F238E27FC236}">
-                <a16:creationId xmlns:a16="http://schemas.microsoft.com/office/drawing/2014/main" id="{A6DCE4AF-C2E0-4B16-B492-B08147A83713}"/>
+                <a16:creationId xmlns:a16="http://schemas.microsoft.com/office/drawing/2014/main" id="{7AEF7E8C-6055-4D42-B641-D0B18F88E4BB}"/>
               </a:ext>
             </a:extLst>
           </p:cNvPr>
@@ -6132,7 +6132,7 @@
           <p:cNvPr id="2" name="">
             <a:extLst xmlns:a="http://schemas.openxmlformats.org/drawingml/2006/main">
               <a:ext uri="{FF2B5EF4-FFF2-40B4-BE49-F238E27FC236}">
-                <a16:creationId xmlns:a16="http://schemas.microsoft.com/office/drawing/2014/main" id="{DD2A66A4-D182-499E-A7A9-AD2270B88EAE}"/>
+                <a16:creationId xmlns:a16="http://schemas.microsoft.com/office/drawing/2014/main" id="{A2A0D2BC-0442-49C3-B22A-DB5079DDC1A3}"/>
               </a:ext>
             </a:extLst>
           </p:cNvPr>
@@ -6190,7 +6190,7 @@
           <p:cNvPr id="3" name="">
             <a:extLst xmlns:a="http://schemas.openxmlformats.org/drawingml/2006/main">
               <a:ext uri="{FF2B5EF4-FFF2-40B4-BE49-F238E27FC236}">
-                <a16:creationId xmlns:a16="http://schemas.microsoft.com/office/drawing/2014/main" id="{CE28B15C-F39B-4863-8636-1D492EE03D78}"/>
+                <a16:creationId xmlns:a16="http://schemas.microsoft.com/office/drawing/2014/main" id="{83732D94-A45A-4320-B1E7-8D1C61B6F6B4}"/>
               </a:ext>
             </a:extLst>
           </p:cNvPr>
@@ -6248,7 +6248,7 @@
           <p:cNvPr id="4" name="">
             <a:extLst xmlns:a="http://schemas.openxmlformats.org/drawingml/2006/main">
               <a:ext uri="{FF2B5EF4-FFF2-40B4-BE49-F238E27FC236}">
-                <a16:creationId xmlns:a16="http://schemas.microsoft.com/office/drawing/2014/main" id="{CE92F4EA-9C2A-40D5-A895-C399B6D96CFD}"/>
+                <a16:creationId xmlns:a16="http://schemas.microsoft.com/office/drawing/2014/main" id="{C497A86C-3C02-4125-AB76-3D30E1D55F8D}"/>
               </a:ext>
             </a:extLst>
           </p:cNvPr>
@@ -6279,7 +6279,7 @@
           <p:cNvPr id="5" name="">
             <a:extLst xmlns:a="http://schemas.openxmlformats.org/drawingml/2006/main">
               <a:ext uri="{FF2B5EF4-FFF2-40B4-BE49-F238E27FC236}">
-                <a16:creationId xmlns:a16="http://schemas.microsoft.com/office/drawing/2014/main" id="{543E91FD-690D-4E72-B542-042053F5334E}"/>
+                <a16:creationId xmlns:a16="http://schemas.microsoft.com/office/drawing/2014/main" id="{C90D9891-9F3D-4CF1-85B9-0BC4073C3B91}"/>
               </a:ext>
             </a:extLst>
           </p:cNvPr>
@@ -6337,7 +6337,7 @@
           <p:cNvPr id="6" name="">
             <a:extLst xmlns:a="http://schemas.openxmlformats.org/drawingml/2006/main">
               <a:ext uri="{FF2B5EF4-FFF2-40B4-BE49-F238E27FC236}">
-                <a16:creationId xmlns:a16="http://schemas.microsoft.com/office/drawing/2014/main" id="{2CCE9699-0767-45F9-BE70-257A7A90971C}"/>
+                <a16:creationId xmlns:a16="http://schemas.microsoft.com/office/drawing/2014/main" id="{DC64EA5F-C62F-4F6E-958A-84D08A97E292}"/>
               </a:ext>
             </a:extLst>
           </p:cNvPr>
@@ -6395,7 +6395,7 @@
           <p:cNvPr id="7" name="">
             <a:extLst xmlns:a="http://schemas.openxmlformats.org/drawingml/2006/main">
               <a:ext uri="{FF2B5EF4-FFF2-40B4-BE49-F238E27FC236}">
-                <a16:creationId xmlns:a16="http://schemas.microsoft.com/office/drawing/2014/main" id="{0A135C98-F9CD-46F2-805A-CBCF4C20B5D0}"/>
+                <a16:creationId xmlns:a16="http://schemas.microsoft.com/office/drawing/2014/main" id="{F265AAB7-7D70-4C49-85CE-99CC016F7DF2}"/>
               </a:ext>
             </a:extLst>
           </p:cNvPr>
@@ -6453,7 +6453,7 @@
           <p:cNvPr id="8" name="">
             <a:extLst xmlns:a="http://schemas.openxmlformats.org/drawingml/2006/main">
               <a:ext uri="{FF2B5EF4-FFF2-40B4-BE49-F238E27FC236}">
-                <a16:creationId xmlns:a16="http://schemas.microsoft.com/office/drawing/2014/main" id="{ED477A13-2FD3-4400-BF02-EA2C8A1DC54F}"/>
+                <a16:creationId xmlns:a16="http://schemas.microsoft.com/office/drawing/2014/main" id="{4727FB82-2361-4772-B5E6-FC8C6733DEDC}"/>
               </a:ext>
             </a:extLst>
           </p:cNvPr>
@@ -6484,7 +6484,7 @@
           <p:cNvPr id="9" name="">
             <a:extLst xmlns:a="http://schemas.openxmlformats.org/drawingml/2006/main">
               <a:ext uri="{FF2B5EF4-FFF2-40B4-BE49-F238E27FC236}">
-                <a16:creationId xmlns:a16="http://schemas.microsoft.com/office/drawing/2014/main" id="{630D60D3-9E07-452D-9DE7-15C9405D09BF}"/>
+                <a16:creationId xmlns:a16="http://schemas.microsoft.com/office/drawing/2014/main" id="{FA855B88-6FE6-4EEA-B628-7CB632D410A0}"/>
               </a:ext>
             </a:extLst>
           </p:cNvPr>
@@ -6542,7 +6542,7 @@
           <p:cNvPr id="10" name="">
             <a:extLst xmlns:a="http://schemas.openxmlformats.org/drawingml/2006/main">
               <a:ext uri="{FF2B5EF4-FFF2-40B4-BE49-F238E27FC236}">
-                <a16:creationId xmlns:a16="http://schemas.microsoft.com/office/drawing/2014/main" id="{1098D1B6-2CCA-497A-8024-833EC23DC147}"/>
+                <a16:creationId xmlns:a16="http://schemas.microsoft.com/office/drawing/2014/main" id="{B5045C3F-A6C9-4B10-9977-E50B0F4BC007}"/>
               </a:ext>
             </a:extLst>
           </p:cNvPr>
@@ -6600,7 +6600,7 @@
           <p:cNvPr id="11" name="">
             <a:extLst xmlns:a="http://schemas.openxmlformats.org/drawingml/2006/main">
               <a:ext uri="{FF2B5EF4-FFF2-40B4-BE49-F238E27FC236}">
-                <a16:creationId xmlns:a16="http://schemas.microsoft.com/office/drawing/2014/main" id="{69E31FE8-58C9-4E8F-BBA1-DC2BB142FBD8}"/>
+                <a16:creationId xmlns:a16="http://schemas.microsoft.com/office/drawing/2014/main" id="{8C811E42-C9C0-4A82-8CA0-5F8D938B1377}"/>
               </a:ext>
             </a:extLst>
           </p:cNvPr>
@@ -6658,7 +6658,7 @@
           <p:cNvPr id="12" name="">
             <a:extLst xmlns:a="http://schemas.openxmlformats.org/drawingml/2006/main">
               <a:ext uri="{FF2B5EF4-FFF2-40B4-BE49-F238E27FC236}">
-                <a16:creationId xmlns:a16="http://schemas.microsoft.com/office/drawing/2014/main" id="{903D338C-BED1-4906-87D3-6C89E3BB8D7A}"/>
+                <a16:creationId xmlns:a16="http://schemas.microsoft.com/office/drawing/2014/main" id="{CE69B2F5-E767-45E6-9E08-27F011B7507E}"/>
               </a:ext>
             </a:extLst>
           </p:cNvPr>
@@ -6716,7 +6716,7 @@
           <p:cNvPr id="13" name="">
             <a:extLst xmlns:a="http://schemas.openxmlformats.org/drawingml/2006/main">
               <a:ext uri="{FF2B5EF4-FFF2-40B4-BE49-F238E27FC236}">
-                <a16:creationId xmlns:a16="http://schemas.microsoft.com/office/drawing/2014/main" id="{1AF299C8-F882-4604-886E-89C0EC1E8478}"/>
+                <a16:creationId xmlns:a16="http://schemas.microsoft.com/office/drawing/2014/main" id="{DC37D443-8B9B-4C72-84F0-2F36970ADE5B}"/>
               </a:ext>
             </a:extLst>
           </p:cNvPr>
@@ -6747,7 +6747,7 @@
           <p:cNvPr id="14" name="">
             <a:extLst xmlns:a="http://schemas.openxmlformats.org/drawingml/2006/main">
               <a:ext uri="{FF2B5EF4-FFF2-40B4-BE49-F238E27FC236}">
-                <a16:creationId xmlns:a16="http://schemas.microsoft.com/office/drawing/2014/main" id="{5605921B-267C-405C-8114-614AC851A588}"/>
+                <a16:creationId xmlns:a16="http://schemas.microsoft.com/office/drawing/2014/main" id="{DC551983-8C14-4500-8594-0148D81A4F89}"/>
               </a:ext>
             </a:extLst>
           </p:cNvPr>
@@ -6805,7 +6805,7 @@
           <p:cNvPr id="15" name="">
             <a:extLst xmlns:a="http://schemas.openxmlformats.org/drawingml/2006/main">
               <a:ext uri="{FF2B5EF4-FFF2-40B4-BE49-F238E27FC236}">
-                <a16:creationId xmlns:a16="http://schemas.microsoft.com/office/drawing/2014/main" id="{D553B3C9-E576-48C1-98D6-08447C5AD06D}"/>
+                <a16:creationId xmlns:a16="http://schemas.microsoft.com/office/drawing/2014/main" id="{AF84BA51-F710-4EB2-B655-4961A3086D61}"/>
               </a:ext>
             </a:extLst>
           </p:cNvPr>
@@ -6861,7 +6861,7 @@
     </p:spTree>
     <p:extLst>
       <p:ext uri="{BB962C8B-B14F-4D97-AF65-F5344CB8AC3E}">
-        <p14:creationId xmlns:p14="http://schemas.microsoft.com/office/powerpoint/2010/main" val="980668740"/>
+        <p14:creationId xmlns:p14="http://schemas.microsoft.com/office/powerpoint/2010/main" val="1789459488"/>
       </p:ext>
     </p:extLst>
   </p:cSld>
@@ -6892,7 +6892,7 @@
           <p:cNvPr id="20" name="">
             <a:extLst xmlns:a="http://schemas.openxmlformats.org/drawingml/2006/main">
               <a:ext uri="{FF2B5EF4-FFF2-40B4-BE49-F238E27FC236}">
-                <a16:creationId xmlns:a16="http://schemas.microsoft.com/office/drawing/2014/main" id="{2AC56934-6822-467B-95BD-957D9339EF78}"/>
+                <a16:creationId xmlns:a16="http://schemas.microsoft.com/office/drawing/2014/main" id="{8A0667A3-1E32-4345-B594-859682E5E65C}"/>
               </a:ext>
             </a:extLst>
           </p:cNvPr>
@@ -6950,7 +6950,7 @@
           <p:cNvPr id="2" name="">
             <a:extLst xmlns:a="http://schemas.openxmlformats.org/drawingml/2006/main">
               <a:ext uri="{FF2B5EF4-FFF2-40B4-BE49-F238E27FC236}">
-                <a16:creationId xmlns:a16="http://schemas.microsoft.com/office/drawing/2014/main" id="{7A9AD605-E43C-409D-8D4E-DAA9890F4899}"/>
+                <a16:creationId xmlns:a16="http://schemas.microsoft.com/office/drawing/2014/main" id="{0010DE44-9111-42FC-AE9C-2341E5CB5A1F}"/>
               </a:ext>
             </a:extLst>
           </p:cNvPr>
@@ -7008,7 +7008,7 @@
           <p:cNvPr id="3" name="">
             <a:extLst xmlns:a="http://schemas.openxmlformats.org/drawingml/2006/main">
               <a:ext uri="{FF2B5EF4-FFF2-40B4-BE49-F238E27FC236}">
-                <a16:creationId xmlns:a16="http://schemas.microsoft.com/office/drawing/2014/main" id="{C6CD8C57-7A04-4E84-86AE-8E02C4957AB8}"/>
+                <a16:creationId xmlns:a16="http://schemas.microsoft.com/office/drawing/2014/main" id="{0D43AC9B-A11E-4F68-A32F-400E5E974A2E}"/>
               </a:ext>
             </a:extLst>
           </p:cNvPr>
@@ -7039,7 +7039,7 @@
           <p:cNvPr id="4" name="">
             <a:extLst xmlns:a="http://schemas.openxmlformats.org/drawingml/2006/main">
               <a:ext uri="{FF2B5EF4-FFF2-40B4-BE49-F238E27FC236}">
-                <a16:creationId xmlns:a16="http://schemas.microsoft.com/office/drawing/2014/main" id="{24336FE5-0C22-49DE-8680-E19B94DA1D20}"/>
+                <a16:creationId xmlns:a16="http://schemas.microsoft.com/office/drawing/2014/main" id="{16C23288-FC7E-4E66-BA74-FA4415B2669B}"/>
               </a:ext>
             </a:extLst>
           </p:cNvPr>
@@ -7097,7 +7097,7 @@
           <p:cNvPr id="5" name="">
             <a:extLst xmlns:a="http://schemas.openxmlformats.org/drawingml/2006/main">
               <a:ext uri="{FF2B5EF4-FFF2-40B4-BE49-F238E27FC236}">
-                <a16:creationId xmlns:a16="http://schemas.microsoft.com/office/drawing/2014/main" id="{1CDA79AB-1C1D-4B67-B12C-BEE05B697F22}"/>
+                <a16:creationId xmlns:a16="http://schemas.microsoft.com/office/drawing/2014/main" id="{58BF50E2-31E8-4AE4-A7DE-8CDEA8101D1F}"/>
               </a:ext>
             </a:extLst>
           </p:cNvPr>
@@ -7178,7 +7178,7 @@
           <p:cNvPr id="6" name="">
             <a:extLst xmlns:a="http://schemas.openxmlformats.org/drawingml/2006/main">
               <a:ext uri="{FF2B5EF4-FFF2-40B4-BE49-F238E27FC236}">
-                <a16:creationId xmlns:a16="http://schemas.microsoft.com/office/drawing/2014/main" id="{776A8CBB-9E4C-48B3-8502-1A8E7B273DAD}"/>
+                <a16:creationId xmlns:a16="http://schemas.microsoft.com/office/drawing/2014/main" id="{EBB058C0-4138-4F0D-91F1-A9D295D58019}"/>
               </a:ext>
             </a:extLst>
           </p:cNvPr>
@@ -7236,7 +7236,7 @@
           <p:cNvPr id="7" name="">
             <a:extLst xmlns:a="http://schemas.openxmlformats.org/drawingml/2006/main">
               <a:ext uri="{FF2B5EF4-FFF2-40B4-BE49-F238E27FC236}">
-                <a16:creationId xmlns:a16="http://schemas.microsoft.com/office/drawing/2014/main" id="{C0DDD64F-AB3D-482D-86EE-DCFF2DD73D30}"/>
+                <a16:creationId xmlns:a16="http://schemas.microsoft.com/office/drawing/2014/main" id="{5CF3A6B9-E772-4AAC-A84D-4492D8538414}"/>
               </a:ext>
             </a:extLst>
           </p:cNvPr>
@@ -7267,7 +7267,7 @@
           <p:cNvPr id="8" name="">
             <a:extLst xmlns:a="http://schemas.openxmlformats.org/drawingml/2006/main">
               <a:ext uri="{FF2B5EF4-FFF2-40B4-BE49-F238E27FC236}">
-                <a16:creationId xmlns:a16="http://schemas.microsoft.com/office/drawing/2014/main" id="{999FFD8D-A700-4CFE-9A26-A044D5490992}"/>
+                <a16:creationId xmlns:a16="http://schemas.microsoft.com/office/drawing/2014/main" id="{39DBDE65-C321-463A-8DE8-A0B59C350CDB}"/>
               </a:ext>
             </a:extLst>
           </p:cNvPr>
@@ -7325,7 +7325,7 @@
           <p:cNvPr id="9" name="">
             <a:extLst xmlns:a="http://schemas.openxmlformats.org/drawingml/2006/main">
               <a:ext uri="{FF2B5EF4-FFF2-40B4-BE49-F238E27FC236}">
-                <a16:creationId xmlns:a16="http://schemas.microsoft.com/office/drawing/2014/main" id="{54229AA4-93C6-4F48-B484-40B794974DD6}"/>
+                <a16:creationId xmlns:a16="http://schemas.microsoft.com/office/drawing/2014/main" id="{B4C72FF5-F637-4D49-A13B-538EAE7CEBED}"/>
               </a:ext>
             </a:extLst>
           </p:cNvPr>
@@ -7406,7 +7406,7 @@
           <p:cNvPr id="10" name="">
             <a:extLst xmlns:a="http://schemas.openxmlformats.org/drawingml/2006/main">
               <a:ext uri="{FF2B5EF4-FFF2-40B4-BE49-F238E27FC236}">
-                <a16:creationId xmlns:a16="http://schemas.microsoft.com/office/drawing/2014/main" id="{142528AC-438F-40A1-831B-1FB0EC2CF7C3}"/>
+                <a16:creationId xmlns:a16="http://schemas.microsoft.com/office/drawing/2014/main" id="{907903CE-5E14-4998-A461-82B3BDF1ABD3}"/>
               </a:ext>
             </a:extLst>
           </p:cNvPr>
@@ -7464,7 +7464,7 @@
           <p:cNvPr id="11" name="">
             <a:extLst xmlns:a="http://schemas.openxmlformats.org/drawingml/2006/main">
               <a:ext uri="{FF2B5EF4-FFF2-40B4-BE49-F238E27FC236}">
-                <a16:creationId xmlns:a16="http://schemas.microsoft.com/office/drawing/2014/main" id="{D7ED1F85-6D16-42B6-9BF6-67179D92C593}"/>
+                <a16:creationId xmlns:a16="http://schemas.microsoft.com/office/drawing/2014/main" id="{35F79A5A-1C98-47D4-A7A7-AEAF11F8FF58}"/>
               </a:ext>
             </a:extLst>
           </p:cNvPr>
@@ -7495,7 +7495,7 @@
           <p:cNvPr id="12" name="">
             <a:extLst xmlns:a="http://schemas.openxmlformats.org/drawingml/2006/main">
               <a:ext uri="{FF2B5EF4-FFF2-40B4-BE49-F238E27FC236}">
-                <a16:creationId xmlns:a16="http://schemas.microsoft.com/office/drawing/2014/main" id="{50CA53D7-F2AD-4D2F-A7BF-EFB04D23D880}"/>
+                <a16:creationId xmlns:a16="http://schemas.microsoft.com/office/drawing/2014/main" id="{40BB20FE-1438-453B-8AEF-D840F596F357}"/>
               </a:ext>
             </a:extLst>
           </p:cNvPr>
@@ -7553,7 +7553,7 @@
           <p:cNvPr id="13" name="">
             <a:extLst xmlns:a="http://schemas.openxmlformats.org/drawingml/2006/main">
               <a:ext uri="{FF2B5EF4-FFF2-40B4-BE49-F238E27FC236}">
-                <a16:creationId xmlns:a16="http://schemas.microsoft.com/office/drawing/2014/main" id="{572A1B99-FE89-4494-BE33-6690F1F9D088}"/>
+                <a16:creationId xmlns:a16="http://schemas.microsoft.com/office/drawing/2014/main" id="{0A35A47A-41CE-48D9-80E7-B0B70B5BF4CA}"/>
               </a:ext>
             </a:extLst>
           </p:cNvPr>
@@ -7634,7 +7634,7 @@
           <p:cNvPr id="14" name="">
             <a:extLst xmlns:a="http://schemas.openxmlformats.org/drawingml/2006/main">
               <a:ext uri="{FF2B5EF4-FFF2-40B4-BE49-F238E27FC236}">
-                <a16:creationId xmlns:a16="http://schemas.microsoft.com/office/drawing/2014/main" id="{D7613AEC-4F73-4EC7-95FA-3655C1935D4D}"/>
+                <a16:creationId xmlns:a16="http://schemas.microsoft.com/office/drawing/2014/main" id="{F0BAFD9C-6A60-4664-8B5B-E0A8A08BA1AE}"/>
               </a:ext>
             </a:extLst>
           </p:cNvPr>
@@ -7667,7 +7667,7 @@
           <p:cNvPr id="15" name="">
             <a:extLst xmlns:a="http://schemas.openxmlformats.org/drawingml/2006/main">
               <a:ext uri="{FF2B5EF4-FFF2-40B4-BE49-F238E27FC236}">
-                <a16:creationId xmlns:a16="http://schemas.microsoft.com/office/drawing/2014/main" id="{E96E0DDD-2CDD-4278-A22F-F8665EA723BF}"/>
+                <a16:creationId xmlns:a16="http://schemas.microsoft.com/office/drawing/2014/main" id="{EA846D99-C6F2-4889-8A49-39A57EAD4140}"/>
               </a:ext>
             </a:extLst>
           </p:cNvPr>
@@ -7725,7 +7725,7 @@
           <p:cNvPr id="16" name="">
             <a:extLst xmlns:a="http://schemas.openxmlformats.org/drawingml/2006/main">
               <a:ext uri="{FF2B5EF4-FFF2-40B4-BE49-F238E27FC236}">
-                <a16:creationId xmlns:a16="http://schemas.microsoft.com/office/drawing/2014/main" id="{2D0C90C5-3F16-446C-AA87-CF9E64C91259}"/>
+                <a16:creationId xmlns:a16="http://schemas.microsoft.com/office/drawing/2014/main" id="{D828E4FE-BB45-4A63-8641-C5F92C952C04}"/>
               </a:ext>
             </a:extLst>
           </p:cNvPr>
@@ -7806,7 +7806,7 @@
           <p:cNvPr id="17" name="">
             <a:extLst xmlns:a="http://schemas.openxmlformats.org/drawingml/2006/main">
               <a:ext uri="{FF2B5EF4-FFF2-40B4-BE49-F238E27FC236}">
-                <a16:creationId xmlns:a16="http://schemas.microsoft.com/office/drawing/2014/main" id="{1851F0B1-1C54-4108-90F3-556E383E2756}"/>
+                <a16:creationId xmlns:a16="http://schemas.microsoft.com/office/drawing/2014/main" id="{DED87B48-654D-4D5A-A49F-90ECCBA7CEBF}"/>
               </a:ext>
             </a:extLst>
           </p:cNvPr>
@@ -7837,7 +7837,7 @@
           <p:cNvPr id="18" name="">
             <a:extLst xmlns:a="http://schemas.openxmlformats.org/drawingml/2006/main">
               <a:ext uri="{FF2B5EF4-FFF2-40B4-BE49-F238E27FC236}">
-                <a16:creationId xmlns:a16="http://schemas.microsoft.com/office/drawing/2014/main" id="{6149D74A-B679-4ABF-BD1E-47358CEB8D1C}"/>
+                <a16:creationId xmlns:a16="http://schemas.microsoft.com/office/drawing/2014/main" id="{571DBA9C-870D-4AE3-A3B5-9A9821B9F578}"/>
               </a:ext>
             </a:extLst>
           </p:cNvPr>
@@ -7895,7 +7895,7 @@
           <p:cNvPr id="19" name="">
             <a:extLst xmlns:a="http://schemas.openxmlformats.org/drawingml/2006/main">
               <a:ext uri="{FF2B5EF4-FFF2-40B4-BE49-F238E27FC236}">
-                <a16:creationId xmlns:a16="http://schemas.microsoft.com/office/drawing/2014/main" id="{6739575C-4E25-4AF4-853B-F8DFB4EA4F02}"/>
+                <a16:creationId xmlns:a16="http://schemas.microsoft.com/office/drawing/2014/main" id="{09B60F8D-C2BF-4882-87B5-B61316656F6C}"/>
               </a:ext>
             </a:extLst>
           </p:cNvPr>
@@ -7951,7 +7951,7 @@
     </p:spTree>
     <p:extLst>
       <p:ext uri="{BB962C8B-B14F-4D97-AF65-F5344CB8AC3E}">
-        <p14:creationId xmlns:p14="http://schemas.microsoft.com/office/powerpoint/2010/main" val="1324083842"/>
+        <p14:creationId xmlns:p14="http://schemas.microsoft.com/office/powerpoint/2010/main" val="678812039"/>
       </p:ext>
     </p:extLst>
   </p:cSld>
@@ -7982,7 +7982,7 @@
           <p:cNvPr id="28" name="">
             <a:extLst xmlns:a="http://schemas.openxmlformats.org/drawingml/2006/main">
               <a:ext uri="{FF2B5EF4-FFF2-40B4-BE49-F238E27FC236}">
-                <a16:creationId xmlns:a16="http://schemas.microsoft.com/office/drawing/2014/main" id="{F6B1E932-C7A9-4ADB-970A-1C29A08D42BB}"/>
+                <a16:creationId xmlns:a16="http://schemas.microsoft.com/office/drawing/2014/main" id="{C0624F62-697C-4AE8-91C8-59FF076FA8C2}"/>
               </a:ext>
             </a:extLst>
           </p:cNvPr>
@@ -8040,7 +8040,7 @@
           <p:cNvPr id="2" name="">
             <a:extLst xmlns:a="http://schemas.openxmlformats.org/drawingml/2006/main">
               <a:ext uri="{FF2B5EF4-FFF2-40B4-BE49-F238E27FC236}">
-                <a16:creationId xmlns:a16="http://schemas.microsoft.com/office/drawing/2014/main" id="{B674EAEC-7304-464B-86E1-CDDAD4BBAB01}"/>
+                <a16:creationId xmlns:a16="http://schemas.microsoft.com/office/drawing/2014/main" id="{2D125547-7116-44D6-9C20-DB15697FA50A}"/>
               </a:ext>
             </a:extLst>
           </p:cNvPr>
@@ -8098,7 +8098,7 @@
           <p:cNvPr id="3" name="">
             <a:extLst xmlns:a="http://schemas.openxmlformats.org/drawingml/2006/main">
               <a:ext uri="{FF2B5EF4-FFF2-40B4-BE49-F238E27FC236}">
-                <a16:creationId xmlns:a16="http://schemas.microsoft.com/office/drawing/2014/main" id="{A05006EE-6CE5-4F6B-AC33-53C23AB442E4}"/>
+                <a16:creationId xmlns:a16="http://schemas.microsoft.com/office/drawing/2014/main" id="{10AD8681-C343-4FCD-8CA3-E4DB3B1BDB33}"/>
               </a:ext>
             </a:extLst>
           </p:cNvPr>
@@ -8129,7 +8129,7 @@
           <p:cNvPr id="4" name="">
             <a:extLst xmlns:a="http://schemas.openxmlformats.org/drawingml/2006/main">
               <a:ext uri="{FF2B5EF4-FFF2-40B4-BE49-F238E27FC236}">
-                <a16:creationId xmlns:a16="http://schemas.microsoft.com/office/drawing/2014/main" id="{F15D5C91-7717-4DA1-90F7-8B67B641FBF2}"/>
+                <a16:creationId xmlns:a16="http://schemas.microsoft.com/office/drawing/2014/main" id="{3CDB1724-3B13-4AC7-85FB-5A15D73CD6CE}"/>
               </a:ext>
             </a:extLst>
           </p:cNvPr>
@@ -8187,7 +8187,7 @@
           <p:cNvPr id="5" name="">
             <a:extLst xmlns:a="http://schemas.openxmlformats.org/drawingml/2006/main">
               <a:ext uri="{FF2B5EF4-FFF2-40B4-BE49-F238E27FC236}">
-                <a16:creationId xmlns:a16="http://schemas.microsoft.com/office/drawing/2014/main" id="{6CF2C65E-7A63-412B-98F1-7F06BCA39E98}"/>
+                <a16:creationId xmlns:a16="http://schemas.microsoft.com/office/drawing/2014/main" id="{A05245CA-C177-4B56-B4AD-ACEAD4940C90}"/>
               </a:ext>
             </a:extLst>
           </p:cNvPr>
@@ -8245,7 +8245,7 @@
           <p:cNvPr id="6" name="">
             <a:extLst xmlns:a="http://schemas.openxmlformats.org/drawingml/2006/main">
               <a:ext uri="{FF2B5EF4-FFF2-40B4-BE49-F238E27FC236}">
-                <a16:creationId xmlns:a16="http://schemas.microsoft.com/office/drawing/2014/main" id="{91A2AF7D-BA26-4A8E-A48E-CDAE4A3630C6}"/>
+                <a16:creationId xmlns:a16="http://schemas.microsoft.com/office/drawing/2014/main" id="{066A23AF-C137-417C-AE31-B6627C177A3E}"/>
               </a:ext>
             </a:extLst>
           </p:cNvPr>
@@ -8303,7 +8303,7 @@
           <p:cNvPr id="7" name="">
             <a:extLst xmlns:a="http://schemas.openxmlformats.org/drawingml/2006/main">
               <a:ext uri="{FF2B5EF4-FFF2-40B4-BE49-F238E27FC236}">
-                <a16:creationId xmlns:a16="http://schemas.microsoft.com/office/drawing/2014/main" id="{18AE9736-25FA-4B46-A336-76607E755912}"/>
+                <a16:creationId xmlns:a16="http://schemas.microsoft.com/office/drawing/2014/main" id="{144ADD21-9849-49CD-8649-A33722D83747}"/>
               </a:ext>
             </a:extLst>
           </p:cNvPr>
@@ -8361,7 +8361,7 @@
           <p:cNvPr id="8" name="">
             <a:extLst xmlns:a="http://schemas.openxmlformats.org/drawingml/2006/main">
               <a:ext uri="{FF2B5EF4-FFF2-40B4-BE49-F238E27FC236}">
-                <a16:creationId xmlns:a16="http://schemas.microsoft.com/office/drawing/2014/main" id="{E372B7FC-704C-41EB-AAF9-A6FF2C89818D}"/>
+                <a16:creationId xmlns:a16="http://schemas.microsoft.com/office/drawing/2014/main" id="{4447A476-230B-4DF4-99DB-53BA39536973}"/>
               </a:ext>
             </a:extLst>
           </p:cNvPr>
@@ -8392,7 +8392,7 @@
           <p:cNvPr id="9" name="">
             <a:extLst xmlns:a="http://schemas.openxmlformats.org/drawingml/2006/main">
               <a:ext uri="{FF2B5EF4-FFF2-40B4-BE49-F238E27FC236}">
-                <a16:creationId xmlns:a16="http://schemas.microsoft.com/office/drawing/2014/main" id="{4E293E4E-3795-4387-A882-72677248B892}"/>
+                <a16:creationId xmlns:a16="http://schemas.microsoft.com/office/drawing/2014/main" id="{14C0DFB9-4E06-4031-9FC5-C2BECF5B2F5A}"/>
               </a:ext>
             </a:extLst>
           </p:cNvPr>
@@ -8450,7 +8450,7 @@
           <p:cNvPr id="10" name="">
             <a:extLst xmlns:a="http://schemas.openxmlformats.org/drawingml/2006/main">
               <a:ext uri="{FF2B5EF4-FFF2-40B4-BE49-F238E27FC236}">
-                <a16:creationId xmlns:a16="http://schemas.microsoft.com/office/drawing/2014/main" id="{654FE22C-DEE5-4C65-A465-BD3F319B2070}"/>
+                <a16:creationId xmlns:a16="http://schemas.microsoft.com/office/drawing/2014/main" id="{CFED4280-A808-4A2C-8E5F-AB79A8CC5872}"/>
               </a:ext>
             </a:extLst>
           </p:cNvPr>
@@ -8508,7 +8508,7 @@
           <p:cNvPr id="11" name="">
             <a:extLst xmlns:a="http://schemas.openxmlformats.org/drawingml/2006/main">
               <a:ext uri="{FF2B5EF4-FFF2-40B4-BE49-F238E27FC236}">
-                <a16:creationId xmlns:a16="http://schemas.microsoft.com/office/drawing/2014/main" id="{28688826-3DE1-4133-B023-398B1274EAB8}"/>
+                <a16:creationId xmlns:a16="http://schemas.microsoft.com/office/drawing/2014/main" id="{1571D6F8-6F50-4524-9CE5-4D5BFB59E459}"/>
               </a:ext>
             </a:extLst>
           </p:cNvPr>
@@ -8566,7 +8566,7 @@
           <p:cNvPr id="12" name="">
             <a:extLst xmlns:a="http://schemas.openxmlformats.org/drawingml/2006/main">
               <a:ext uri="{FF2B5EF4-FFF2-40B4-BE49-F238E27FC236}">
-                <a16:creationId xmlns:a16="http://schemas.microsoft.com/office/drawing/2014/main" id="{DA2F2CDA-4D07-4098-A9B9-A7CA06B090D2}"/>
+                <a16:creationId xmlns:a16="http://schemas.microsoft.com/office/drawing/2014/main" id="{7BA557CD-B4CF-4127-B42D-A3A414B7BDE2}"/>
               </a:ext>
             </a:extLst>
           </p:cNvPr>
@@ -8624,7 +8624,7 @@
           <p:cNvPr id="13" name="">
             <a:extLst xmlns:a="http://schemas.openxmlformats.org/drawingml/2006/main">
               <a:ext uri="{FF2B5EF4-FFF2-40B4-BE49-F238E27FC236}">
-                <a16:creationId xmlns:a16="http://schemas.microsoft.com/office/drawing/2014/main" id="{8D50C8E4-5BAE-42D7-B564-2D2066664F8C}"/>
+                <a16:creationId xmlns:a16="http://schemas.microsoft.com/office/drawing/2014/main" id="{07CF19FA-C491-4D9F-A9D3-B3E3C5694F46}"/>
               </a:ext>
             </a:extLst>
           </p:cNvPr>
@@ -8655,7 +8655,7 @@
           <p:cNvPr id="14" name="">
             <a:extLst xmlns:a="http://schemas.openxmlformats.org/drawingml/2006/main">
               <a:ext uri="{FF2B5EF4-FFF2-40B4-BE49-F238E27FC236}">
-                <a16:creationId xmlns:a16="http://schemas.microsoft.com/office/drawing/2014/main" id="{5871CFF9-4A47-43E4-BF2E-3F6A48DF4419}"/>
+                <a16:creationId xmlns:a16="http://schemas.microsoft.com/office/drawing/2014/main" id="{A0800E28-377E-4024-943D-FE7A4395D0A4}"/>
               </a:ext>
             </a:extLst>
           </p:cNvPr>
@@ -8713,7 +8713,7 @@
           <p:cNvPr id="15" name="">
             <a:extLst xmlns:a="http://schemas.openxmlformats.org/drawingml/2006/main">
               <a:ext uri="{FF2B5EF4-FFF2-40B4-BE49-F238E27FC236}">
-                <a16:creationId xmlns:a16="http://schemas.microsoft.com/office/drawing/2014/main" id="{08D0B8AC-2FDB-4E90-B38E-18A9EFBAB055}"/>
+                <a16:creationId xmlns:a16="http://schemas.microsoft.com/office/drawing/2014/main" id="{62213870-B4CD-4682-AD07-4CBE309C8AB2}"/>
               </a:ext>
             </a:extLst>
           </p:cNvPr>
@@ -8771,7 +8771,7 @@
           <p:cNvPr id="16" name="">
             <a:extLst xmlns:a="http://schemas.openxmlformats.org/drawingml/2006/main">
               <a:ext uri="{FF2B5EF4-FFF2-40B4-BE49-F238E27FC236}">
-                <a16:creationId xmlns:a16="http://schemas.microsoft.com/office/drawing/2014/main" id="{BB7B8801-AC1C-4F03-940B-92B1861F162A}"/>
+                <a16:creationId xmlns:a16="http://schemas.microsoft.com/office/drawing/2014/main" id="{3B1E5502-3A2B-4378-8C26-591FEFBB0F8D}"/>
               </a:ext>
             </a:extLst>
           </p:cNvPr>
@@ -8829,7 +8829,7 @@
           <p:cNvPr id="17" name="">
             <a:extLst xmlns:a="http://schemas.openxmlformats.org/drawingml/2006/main">
               <a:ext uri="{FF2B5EF4-FFF2-40B4-BE49-F238E27FC236}">
-                <a16:creationId xmlns:a16="http://schemas.microsoft.com/office/drawing/2014/main" id="{E97549E8-D599-48E6-9A97-9307C1C74489}"/>
+                <a16:creationId xmlns:a16="http://schemas.microsoft.com/office/drawing/2014/main" id="{BEE86C1C-30DB-40EB-8E5C-8C2514C7D7D7}"/>
               </a:ext>
             </a:extLst>
           </p:cNvPr>
@@ -8887,7 +8887,7 @@
           <p:cNvPr id="18" name="">
             <a:extLst xmlns:a="http://schemas.openxmlformats.org/drawingml/2006/main">
               <a:ext uri="{FF2B5EF4-FFF2-40B4-BE49-F238E27FC236}">
-                <a16:creationId xmlns:a16="http://schemas.microsoft.com/office/drawing/2014/main" id="{3765B1D6-5B79-4410-BE11-975EAF2F6D00}"/>
+                <a16:creationId xmlns:a16="http://schemas.microsoft.com/office/drawing/2014/main" id="{99C433B7-D7AD-4B38-8711-CD0024B52C59}"/>
               </a:ext>
             </a:extLst>
           </p:cNvPr>
@@ -8918,7 +8918,7 @@
           <p:cNvPr id="19" name="">
             <a:extLst xmlns:a="http://schemas.openxmlformats.org/drawingml/2006/main">
               <a:ext uri="{FF2B5EF4-FFF2-40B4-BE49-F238E27FC236}">
-                <a16:creationId xmlns:a16="http://schemas.microsoft.com/office/drawing/2014/main" id="{EB4675DC-A2FC-45CB-8527-1160FD26C43B}"/>
+                <a16:creationId xmlns:a16="http://schemas.microsoft.com/office/drawing/2014/main" id="{F9253966-31B1-47AF-830A-D8B924BF8F1E}"/>
               </a:ext>
             </a:extLst>
           </p:cNvPr>
@@ -8976,7 +8976,7 @@
           <p:cNvPr id="20" name="">
             <a:extLst xmlns:a="http://schemas.openxmlformats.org/drawingml/2006/main">
               <a:ext uri="{FF2B5EF4-FFF2-40B4-BE49-F238E27FC236}">
-                <a16:creationId xmlns:a16="http://schemas.microsoft.com/office/drawing/2014/main" id="{23B8D898-8859-4DA5-BAE0-F3F513384F59}"/>
+                <a16:creationId xmlns:a16="http://schemas.microsoft.com/office/drawing/2014/main" id="{17EC1AE9-3E6D-4E02-93EB-94586B646399}"/>
               </a:ext>
             </a:extLst>
           </p:cNvPr>
@@ -9034,7 +9034,7 @@
           <p:cNvPr id="21" name="">
             <a:extLst xmlns:a="http://schemas.openxmlformats.org/drawingml/2006/main">
               <a:ext uri="{FF2B5EF4-FFF2-40B4-BE49-F238E27FC236}">
-                <a16:creationId xmlns:a16="http://schemas.microsoft.com/office/drawing/2014/main" id="{5DCBFA4B-55B6-4369-BF9F-B47FBA69D9F3}"/>
+                <a16:creationId xmlns:a16="http://schemas.microsoft.com/office/drawing/2014/main" id="{5E2191AD-6347-468E-B95E-B81E13C8F731}"/>
               </a:ext>
             </a:extLst>
           </p:cNvPr>
@@ -9092,7 +9092,7 @@
           <p:cNvPr id="22" name="">
             <a:extLst xmlns:a="http://schemas.openxmlformats.org/drawingml/2006/main">
               <a:ext uri="{FF2B5EF4-FFF2-40B4-BE49-F238E27FC236}">
-                <a16:creationId xmlns:a16="http://schemas.microsoft.com/office/drawing/2014/main" id="{EC3A0AAD-D586-4892-A06B-7C84957E17CD}"/>
+                <a16:creationId xmlns:a16="http://schemas.microsoft.com/office/drawing/2014/main" id="{C58B93FD-AA36-4707-BD03-F88572568838}"/>
               </a:ext>
             </a:extLst>
           </p:cNvPr>
@@ -9123,7 +9123,7 @@
           <p:cNvPr id="23" name="">
             <a:extLst xmlns:a="http://schemas.openxmlformats.org/drawingml/2006/main">
               <a:ext uri="{FF2B5EF4-FFF2-40B4-BE49-F238E27FC236}">
-                <a16:creationId xmlns:a16="http://schemas.microsoft.com/office/drawing/2014/main" id="{61D1D588-A6AE-4EC0-B2BD-3CBE86AB681B}"/>
+                <a16:creationId xmlns:a16="http://schemas.microsoft.com/office/drawing/2014/main" id="{435D9CF5-BCB4-46CA-A04B-474492C3C7AE}"/>
               </a:ext>
             </a:extLst>
           </p:cNvPr>
@@ -9181,7 +9181,7 @@
           <p:cNvPr id="24" name="">
             <a:extLst xmlns:a="http://schemas.openxmlformats.org/drawingml/2006/main">
               <a:ext uri="{FF2B5EF4-FFF2-40B4-BE49-F238E27FC236}">
-                <a16:creationId xmlns:a16="http://schemas.microsoft.com/office/drawing/2014/main" id="{CDC96415-7880-4233-9ABF-DD3343CAF9B5}"/>
+                <a16:creationId xmlns:a16="http://schemas.microsoft.com/office/drawing/2014/main" id="{72FB4740-0740-4963-9DCA-E52B935F1FFB}"/>
               </a:ext>
             </a:extLst>
           </p:cNvPr>
@@ -9239,7 +9239,7 @@
           <p:cNvPr id="25" name="">
             <a:extLst xmlns:a="http://schemas.openxmlformats.org/drawingml/2006/main">
               <a:ext uri="{FF2B5EF4-FFF2-40B4-BE49-F238E27FC236}">
-                <a16:creationId xmlns:a16="http://schemas.microsoft.com/office/drawing/2014/main" id="{349EA07E-55F3-43BE-B316-B9A73E4110F0}"/>
+                <a16:creationId xmlns:a16="http://schemas.microsoft.com/office/drawing/2014/main" id="{BB6F9D94-7595-421B-AE62-AFD2DEF37320}"/>
               </a:ext>
             </a:extLst>
           </p:cNvPr>
@@ -9270,7 +9270,7 @@
           <p:cNvPr id="26" name="">
             <a:extLst xmlns:a="http://schemas.openxmlformats.org/drawingml/2006/main">
               <a:ext uri="{FF2B5EF4-FFF2-40B4-BE49-F238E27FC236}">
-                <a16:creationId xmlns:a16="http://schemas.microsoft.com/office/drawing/2014/main" id="{4E86454D-CEC7-4D64-B5D4-68B69A6F45D9}"/>
+                <a16:creationId xmlns:a16="http://schemas.microsoft.com/office/drawing/2014/main" id="{9F264098-55BF-4ECE-930D-FA0BFDB1F6AB}"/>
               </a:ext>
             </a:extLst>
           </p:cNvPr>
@@ -9328,7 +9328,7 @@
           <p:cNvPr id="27" name="">
             <a:extLst xmlns:a="http://schemas.openxmlformats.org/drawingml/2006/main">
               <a:ext uri="{FF2B5EF4-FFF2-40B4-BE49-F238E27FC236}">
-                <a16:creationId xmlns:a16="http://schemas.microsoft.com/office/drawing/2014/main" id="{193AD8F5-8D84-437A-9BC9-56D1A3582C94}"/>
+                <a16:creationId xmlns:a16="http://schemas.microsoft.com/office/drawing/2014/main" id="{5B8E092E-D29C-404E-805C-0A83C2551B80}"/>
               </a:ext>
             </a:extLst>
           </p:cNvPr>
@@ -9384,7 +9384,7 @@
     </p:spTree>
     <p:extLst>
       <p:ext uri="{BB962C8B-B14F-4D97-AF65-F5344CB8AC3E}">
-        <p14:creationId xmlns:p14="http://schemas.microsoft.com/office/powerpoint/2010/main" val="1789571922"/>
+        <p14:creationId xmlns:p14="http://schemas.microsoft.com/office/powerpoint/2010/main" val="1211000936"/>
       </p:ext>
     </p:extLst>
   </p:cSld>
@@ -9415,7 +9415,7 @@
           <p:cNvPr id="15" name="">
             <a:extLst xmlns:a="http://schemas.openxmlformats.org/drawingml/2006/main">
               <a:ext uri="{FF2B5EF4-FFF2-40B4-BE49-F238E27FC236}">
-                <a16:creationId xmlns:a16="http://schemas.microsoft.com/office/drawing/2014/main" id="{85FD86B6-D07B-460F-A625-EC28CFC417EC}"/>
+                <a16:creationId xmlns:a16="http://schemas.microsoft.com/office/drawing/2014/main" id="{02026B98-CF56-4077-926C-04A755BC8D7A}"/>
               </a:ext>
             </a:extLst>
           </p:cNvPr>
@@ -9473,7 +9473,7 @@
           <p:cNvPr id="2" name="">
             <a:extLst xmlns:a="http://schemas.openxmlformats.org/drawingml/2006/main">
               <a:ext uri="{FF2B5EF4-FFF2-40B4-BE49-F238E27FC236}">
-                <a16:creationId xmlns:a16="http://schemas.microsoft.com/office/drawing/2014/main" id="{C2F550BE-4FFC-4B2E-9938-4E7E9CB7C31E}"/>
+                <a16:creationId xmlns:a16="http://schemas.microsoft.com/office/drawing/2014/main" id="{010B6A4C-A724-4971-9CAB-DB6CC5193BE0}"/>
               </a:ext>
             </a:extLst>
           </p:cNvPr>
@@ -9531,7 +9531,7 @@
           <p:cNvPr id="3" name="">
             <a:extLst xmlns:a="http://schemas.openxmlformats.org/drawingml/2006/main">
               <a:ext uri="{FF2B5EF4-FFF2-40B4-BE49-F238E27FC236}">
-                <a16:creationId xmlns:a16="http://schemas.microsoft.com/office/drawing/2014/main" id="{73726DA0-784A-478C-9929-DBF53447A583}"/>
+                <a16:creationId xmlns:a16="http://schemas.microsoft.com/office/drawing/2014/main" id="{22BEF728-5A92-444F-A4BD-70458D033131}"/>
               </a:ext>
             </a:extLst>
           </p:cNvPr>
@@ -9562,7 +9562,7 @@
           <p:cNvPr id="4" name="">
             <a:extLst xmlns:a="http://schemas.openxmlformats.org/drawingml/2006/main">
               <a:ext uri="{FF2B5EF4-FFF2-40B4-BE49-F238E27FC236}">
-                <a16:creationId xmlns:a16="http://schemas.microsoft.com/office/drawing/2014/main" id="{76679138-1888-4921-81A7-20FBE621ADAF}"/>
+                <a16:creationId xmlns:a16="http://schemas.microsoft.com/office/drawing/2014/main" id="{329D3748-8AE3-4ABC-ADA6-CB89E59F82EA}"/>
               </a:ext>
             </a:extLst>
           </p:cNvPr>
@@ -9620,7 +9620,7 @@
           <p:cNvPr id="5" name="">
             <a:extLst xmlns:a="http://schemas.openxmlformats.org/drawingml/2006/main">
               <a:ext uri="{FF2B5EF4-FFF2-40B4-BE49-F238E27FC236}">
-                <a16:creationId xmlns:a16="http://schemas.microsoft.com/office/drawing/2014/main" id="{77483C03-EBFB-4499-AE9D-E0EACFFC48D3}"/>
+                <a16:creationId xmlns:a16="http://schemas.microsoft.com/office/drawing/2014/main" id="{69C59BFB-5A88-43A0-BF25-0FA7CE66FD85}"/>
               </a:ext>
             </a:extLst>
           </p:cNvPr>
@@ -9678,7 +9678,7 @@
           <p:cNvPr id="6" name="">
             <a:extLst xmlns:a="http://schemas.openxmlformats.org/drawingml/2006/main">
               <a:ext uri="{FF2B5EF4-FFF2-40B4-BE49-F238E27FC236}">
-                <a16:creationId xmlns:a16="http://schemas.microsoft.com/office/drawing/2014/main" id="{77BC4E77-DB31-4209-A9D1-E84FF041095F}"/>
+                <a16:creationId xmlns:a16="http://schemas.microsoft.com/office/drawing/2014/main" id="{05FF8974-47C9-4298-A067-00EDFC919F76}"/>
               </a:ext>
             </a:extLst>
           </p:cNvPr>
@@ -9736,7 +9736,7 @@
           <p:cNvPr id="7" name="">
             <a:extLst xmlns:a="http://schemas.openxmlformats.org/drawingml/2006/main">
               <a:ext uri="{FF2B5EF4-FFF2-40B4-BE49-F238E27FC236}">
-                <a16:creationId xmlns:a16="http://schemas.microsoft.com/office/drawing/2014/main" id="{0871C27B-AF60-49AC-8A33-D45C272AAE11}"/>
+                <a16:creationId xmlns:a16="http://schemas.microsoft.com/office/drawing/2014/main" id="{3DD9B238-C857-42FC-AD43-CF49DF8B8C2C}"/>
               </a:ext>
             </a:extLst>
           </p:cNvPr>
@@ -9767,7 +9767,7 @@
           <p:cNvPr id="8" name="">
             <a:extLst xmlns:a="http://schemas.openxmlformats.org/drawingml/2006/main">
               <a:ext uri="{FF2B5EF4-FFF2-40B4-BE49-F238E27FC236}">
-                <a16:creationId xmlns:a16="http://schemas.microsoft.com/office/drawing/2014/main" id="{20766BCF-2109-4066-BBCE-B83D1DF7B194}"/>
+                <a16:creationId xmlns:a16="http://schemas.microsoft.com/office/drawing/2014/main" id="{093354CD-D981-4BC4-8624-B25E181D336D}"/>
               </a:ext>
             </a:extLst>
           </p:cNvPr>
@@ -9825,7 +9825,7 @@
           <p:cNvPr id="9" name="">
             <a:extLst xmlns:a="http://schemas.openxmlformats.org/drawingml/2006/main">
               <a:ext uri="{FF2B5EF4-FFF2-40B4-BE49-F238E27FC236}">
-                <a16:creationId xmlns:a16="http://schemas.microsoft.com/office/drawing/2014/main" id="{116CC453-462F-46A3-B4A8-6996A9B68660}"/>
+                <a16:creationId xmlns:a16="http://schemas.microsoft.com/office/drawing/2014/main" id="{EAE0BA30-2CDE-435F-AF6F-7836A0166E3B}"/>
               </a:ext>
             </a:extLst>
           </p:cNvPr>
@@ -9883,7 +9883,7 @@
           <p:cNvPr id="10" name="">
             <a:extLst xmlns:a="http://schemas.openxmlformats.org/drawingml/2006/main">
               <a:ext uri="{FF2B5EF4-FFF2-40B4-BE49-F238E27FC236}">
-                <a16:creationId xmlns:a16="http://schemas.microsoft.com/office/drawing/2014/main" id="{6CF9E8F6-B989-48B1-80BB-4F63790E7159}"/>
+                <a16:creationId xmlns:a16="http://schemas.microsoft.com/office/drawing/2014/main" id="{DAD1EE8A-B1D5-4406-80B6-E7B00EC53E84}"/>
               </a:ext>
             </a:extLst>
           </p:cNvPr>
@@ -9941,7 +9941,7 @@
           <p:cNvPr id="11" name="">
             <a:extLst xmlns:a="http://schemas.openxmlformats.org/drawingml/2006/main">
               <a:ext uri="{FF2B5EF4-FFF2-40B4-BE49-F238E27FC236}">
-                <a16:creationId xmlns:a16="http://schemas.microsoft.com/office/drawing/2014/main" id="{9DF3AA3C-F58F-445C-9C91-11F7D9CCB81A}"/>
+                <a16:creationId xmlns:a16="http://schemas.microsoft.com/office/drawing/2014/main" id="{B1624181-E7E1-4241-B205-9C63A0998C88}"/>
               </a:ext>
             </a:extLst>
           </p:cNvPr>
@@ -9999,7 +9999,7 @@
           <p:cNvPr id="12" name="">
             <a:extLst xmlns:a="http://schemas.openxmlformats.org/drawingml/2006/main">
               <a:ext uri="{FF2B5EF4-FFF2-40B4-BE49-F238E27FC236}">
-                <a16:creationId xmlns:a16="http://schemas.microsoft.com/office/drawing/2014/main" id="{7D6B3317-78B2-4DE1-AD41-260AF9D54478}"/>
+                <a16:creationId xmlns:a16="http://schemas.microsoft.com/office/drawing/2014/main" id="{50654A7B-9B46-44A9-A997-3A3EC67B571D}"/>
               </a:ext>
             </a:extLst>
           </p:cNvPr>
@@ -10030,7 +10030,7 @@
           <p:cNvPr id="13" name="">
             <a:extLst xmlns:a="http://schemas.openxmlformats.org/drawingml/2006/main">
               <a:ext uri="{FF2B5EF4-FFF2-40B4-BE49-F238E27FC236}">
-                <a16:creationId xmlns:a16="http://schemas.microsoft.com/office/drawing/2014/main" id="{1675B5A3-BFB7-489F-9288-55C4BE8754ED}"/>
+                <a16:creationId xmlns:a16="http://schemas.microsoft.com/office/drawing/2014/main" id="{A2CD82D3-2E51-4CA7-B47D-5A32095F82BC}"/>
               </a:ext>
             </a:extLst>
           </p:cNvPr>
@@ -10088,7 +10088,7 @@
           <p:cNvPr id="14" name="">
             <a:extLst xmlns:a="http://schemas.openxmlformats.org/drawingml/2006/main">
               <a:ext uri="{FF2B5EF4-FFF2-40B4-BE49-F238E27FC236}">
-                <a16:creationId xmlns:a16="http://schemas.microsoft.com/office/drawing/2014/main" id="{2B4CC2DB-18B9-40F4-88B2-E3152A3B2160}"/>
+                <a16:creationId xmlns:a16="http://schemas.microsoft.com/office/drawing/2014/main" id="{0A59805C-9156-4114-992C-5F70DE131D86}"/>
               </a:ext>
             </a:extLst>
           </p:cNvPr>
@@ -10144,7 +10144,7 @@
     </p:spTree>
     <p:extLst>
       <p:ext uri="{BB962C8B-B14F-4D97-AF65-F5344CB8AC3E}">
-        <p14:creationId xmlns:p14="http://schemas.microsoft.com/office/powerpoint/2010/main" val="441193234"/>
+        <p14:creationId xmlns:p14="http://schemas.microsoft.com/office/powerpoint/2010/main" val="706047978"/>
       </p:ext>
     </p:extLst>
   </p:cSld>
@@ -10175,7 +10175,7 @@
           <p:cNvPr id="20" name="">
             <a:extLst xmlns:a="http://schemas.openxmlformats.org/drawingml/2006/main">
               <a:ext uri="{FF2B5EF4-FFF2-40B4-BE49-F238E27FC236}">
-                <a16:creationId xmlns:a16="http://schemas.microsoft.com/office/drawing/2014/main" id="{A3A4E48A-F421-467E-86FD-D28C3134CE09}"/>
+                <a16:creationId xmlns:a16="http://schemas.microsoft.com/office/drawing/2014/main" id="{5DF11ED2-7952-4F54-A088-3D5C6F400EEA}"/>
               </a:ext>
             </a:extLst>
           </p:cNvPr>
@@ -10233,7 +10233,7 @@
           <p:cNvPr id="2" name="">
             <a:extLst xmlns:a="http://schemas.openxmlformats.org/drawingml/2006/main">
               <a:ext uri="{FF2B5EF4-FFF2-40B4-BE49-F238E27FC236}">
-                <a16:creationId xmlns:a16="http://schemas.microsoft.com/office/drawing/2014/main" id="{B6FE0C95-D99F-4CC7-9137-B90608894940}"/>
+                <a16:creationId xmlns:a16="http://schemas.microsoft.com/office/drawing/2014/main" id="{15634CC9-0243-43DE-8686-AD9B407DD436}"/>
               </a:ext>
             </a:extLst>
           </p:cNvPr>
@@ -10291,7 +10291,7 @@
           <p:cNvPr id="3" name="">
             <a:extLst xmlns:a="http://schemas.openxmlformats.org/drawingml/2006/main">
               <a:ext uri="{FF2B5EF4-FFF2-40B4-BE49-F238E27FC236}">
-                <a16:creationId xmlns:a16="http://schemas.microsoft.com/office/drawing/2014/main" id="{FBCD5B31-ADDF-4B0F-AEC4-F75624CC4A9D}"/>
+                <a16:creationId xmlns:a16="http://schemas.microsoft.com/office/drawing/2014/main" id="{67403133-AA13-47BC-9496-8E9ECCA334E8}"/>
               </a:ext>
             </a:extLst>
           </p:cNvPr>
@@ -10322,7 +10322,7 @@
           <p:cNvPr id="4" name="">
             <a:extLst xmlns:a="http://schemas.openxmlformats.org/drawingml/2006/main">
               <a:ext uri="{FF2B5EF4-FFF2-40B4-BE49-F238E27FC236}">
-                <a16:creationId xmlns:a16="http://schemas.microsoft.com/office/drawing/2014/main" id="{55DB7F0F-8B3C-4C49-BFBC-0FAA56CCE310}"/>
+                <a16:creationId xmlns:a16="http://schemas.microsoft.com/office/drawing/2014/main" id="{A123EC02-FDF6-43AB-9687-D133228C4872}"/>
               </a:ext>
             </a:extLst>
           </p:cNvPr>
@@ -10380,7 +10380,7 @@
           <p:cNvPr id="5" name="">
             <a:extLst xmlns:a="http://schemas.openxmlformats.org/drawingml/2006/main">
               <a:ext uri="{FF2B5EF4-FFF2-40B4-BE49-F238E27FC236}">
-                <a16:creationId xmlns:a16="http://schemas.microsoft.com/office/drawing/2014/main" id="{C6ED1602-A31C-4D34-80BE-DE407B8A1484}"/>
+                <a16:creationId xmlns:a16="http://schemas.microsoft.com/office/drawing/2014/main" id="{6DC252FD-69C0-4AD0-B822-9BDF0FB3E14A}"/>
               </a:ext>
             </a:extLst>
           </p:cNvPr>
@@ -10438,7 +10438,7 @@
           <p:cNvPr id="6" name="">
             <a:extLst xmlns:a="http://schemas.openxmlformats.org/drawingml/2006/main">
               <a:ext uri="{FF2B5EF4-FFF2-40B4-BE49-F238E27FC236}">
-                <a16:creationId xmlns:a16="http://schemas.microsoft.com/office/drawing/2014/main" id="{2F8B8F61-8E1E-4E73-8A67-82FBD92806FC}"/>
+                <a16:creationId xmlns:a16="http://schemas.microsoft.com/office/drawing/2014/main" id="{35C3D0EF-82D0-4674-97AE-C3D5D57D6F0B}"/>
               </a:ext>
             </a:extLst>
           </p:cNvPr>
@@ -10496,7 +10496,7 @@
           <p:cNvPr id="7" name="">
             <a:extLst xmlns:a="http://schemas.openxmlformats.org/drawingml/2006/main">
               <a:ext uri="{FF2B5EF4-FFF2-40B4-BE49-F238E27FC236}">
-                <a16:creationId xmlns:a16="http://schemas.microsoft.com/office/drawing/2014/main" id="{3533866A-09FB-4A3A-BDE2-53883A42CA83}"/>
+                <a16:creationId xmlns:a16="http://schemas.microsoft.com/office/drawing/2014/main" id="{1353CA81-0FF5-4150-9778-963CEAAEB92D}"/>
               </a:ext>
             </a:extLst>
           </p:cNvPr>
@@ -10554,7 +10554,7 @@
           <p:cNvPr id="8" name="">
             <a:extLst xmlns:a="http://schemas.openxmlformats.org/drawingml/2006/main">
               <a:ext uri="{FF2B5EF4-FFF2-40B4-BE49-F238E27FC236}">
-                <a16:creationId xmlns:a16="http://schemas.microsoft.com/office/drawing/2014/main" id="{E3F732F0-353F-4C64-8EB9-3CE462EE9084}"/>
+                <a16:creationId xmlns:a16="http://schemas.microsoft.com/office/drawing/2014/main" id="{6D1CADE9-1262-4BC2-A0C6-7F93DCCEAFC3}"/>
               </a:ext>
             </a:extLst>
           </p:cNvPr>
@@ -10585,7 +10585,7 @@
           <p:cNvPr id="9" name="">
             <a:extLst xmlns:a="http://schemas.openxmlformats.org/drawingml/2006/main">
               <a:ext uri="{FF2B5EF4-FFF2-40B4-BE49-F238E27FC236}">
-                <a16:creationId xmlns:a16="http://schemas.microsoft.com/office/drawing/2014/main" id="{2C409FBD-27AD-4CF6-A5C0-BF21B1E96474}"/>
+                <a16:creationId xmlns:a16="http://schemas.microsoft.com/office/drawing/2014/main" id="{294430CB-E90D-4EDB-9405-8CB7D29075A1}"/>
               </a:ext>
             </a:extLst>
           </p:cNvPr>
@@ -10643,7 +10643,7 @@
           <p:cNvPr id="10" name="">
             <a:extLst xmlns:a="http://schemas.openxmlformats.org/drawingml/2006/main">
               <a:ext uri="{FF2B5EF4-FFF2-40B4-BE49-F238E27FC236}">
-                <a16:creationId xmlns:a16="http://schemas.microsoft.com/office/drawing/2014/main" id="{4CB9D498-7709-4FE5-92D5-89546EFCE984}"/>
+                <a16:creationId xmlns:a16="http://schemas.microsoft.com/office/drawing/2014/main" id="{BEC22C76-CD63-4A3C-81BA-12F9124BEBB7}"/>
               </a:ext>
             </a:extLst>
           </p:cNvPr>
@@ -10701,7 +10701,7 @@
           <p:cNvPr id="11" name="">
             <a:extLst xmlns:a="http://schemas.openxmlformats.org/drawingml/2006/main">
               <a:ext uri="{FF2B5EF4-FFF2-40B4-BE49-F238E27FC236}">
-                <a16:creationId xmlns:a16="http://schemas.microsoft.com/office/drawing/2014/main" id="{FBD479F0-9F67-495E-8F07-0AD041BC3F86}"/>
+                <a16:creationId xmlns:a16="http://schemas.microsoft.com/office/drawing/2014/main" id="{3D4872E4-E374-4774-9EC4-972F29F5A52F}"/>
               </a:ext>
             </a:extLst>
           </p:cNvPr>
@@ -10759,7 +10759,7 @@
           <p:cNvPr id="12" name="">
             <a:extLst xmlns:a="http://schemas.openxmlformats.org/drawingml/2006/main">
               <a:ext uri="{FF2B5EF4-FFF2-40B4-BE49-F238E27FC236}">
-                <a16:creationId xmlns:a16="http://schemas.microsoft.com/office/drawing/2014/main" id="{5C0B0AAF-91E4-4D5F-98A6-23317B35162F}"/>
+                <a16:creationId xmlns:a16="http://schemas.microsoft.com/office/drawing/2014/main" id="{BD1CC63F-C821-40B8-8B16-9D8FBCAE2A3C}"/>
               </a:ext>
             </a:extLst>
           </p:cNvPr>
@@ -10817,7 +10817,7 @@
           <p:cNvPr id="13" name="">
             <a:extLst xmlns:a="http://schemas.openxmlformats.org/drawingml/2006/main">
               <a:ext uri="{FF2B5EF4-FFF2-40B4-BE49-F238E27FC236}">
-                <a16:creationId xmlns:a16="http://schemas.microsoft.com/office/drawing/2014/main" id="{1A9C8429-A0C4-446F-B509-89DD447E2197}"/>
+                <a16:creationId xmlns:a16="http://schemas.microsoft.com/office/drawing/2014/main" id="{9E9E2D81-DB89-4236-BCB8-705223E11F47}"/>
               </a:ext>
             </a:extLst>
           </p:cNvPr>
@@ -10848,7 +10848,7 @@
           <p:cNvPr id="14" name="">
             <a:extLst xmlns:a="http://schemas.openxmlformats.org/drawingml/2006/main">
               <a:ext uri="{FF2B5EF4-FFF2-40B4-BE49-F238E27FC236}">
-                <a16:creationId xmlns:a16="http://schemas.microsoft.com/office/drawing/2014/main" id="{0B0EDB8E-0E85-46B7-A5DD-2484544349A4}"/>
+                <a16:creationId xmlns:a16="http://schemas.microsoft.com/office/drawing/2014/main" id="{D3F02CC7-B1F3-4F65-B3CB-5D2B65D8C2CC}"/>
               </a:ext>
             </a:extLst>
           </p:cNvPr>
@@ -10906,7 +10906,7 @@
           <p:cNvPr id="15" name="">
             <a:extLst xmlns:a="http://schemas.openxmlformats.org/drawingml/2006/main">
               <a:ext uri="{FF2B5EF4-FFF2-40B4-BE49-F238E27FC236}">
-                <a16:creationId xmlns:a16="http://schemas.microsoft.com/office/drawing/2014/main" id="{A9732493-F3D1-4272-9F0A-45FBA8868689}"/>
+                <a16:creationId xmlns:a16="http://schemas.microsoft.com/office/drawing/2014/main" id="{10330010-BC86-4F75-B3BD-6BBBEC9F2260}"/>
               </a:ext>
             </a:extLst>
           </p:cNvPr>
@@ -11010,7 +11010,7 @@
           <p:cNvPr id="16" name="">
             <a:extLst xmlns:a="http://schemas.openxmlformats.org/drawingml/2006/main">
               <a:ext uri="{FF2B5EF4-FFF2-40B4-BE49-F238E27FC236}">
-                <a16:creationId xmlns:a16="http://schemas.microsoft.com/office/drawing/2014/main" id="{B801F8DD-F84D-4878-A266-495AC14F6890}"/>
+                <a16:creationId xmlns:a16="http://schemas.microsoft.com/office/drawing/2014/main" id="{2683765E-566F-4CBC-A4EA-3BEE7E51F2B4}"/>
               </a:ext>
             </a:extLst>
           </p:cNvPr>
@@ -11068,7 +11068,7 @@
           <p:cNvPr id="17" name="">
             <a:extLst xmlns:a="http://schemas.openxmlformats.org/drawingml/2006/main">
               <a:ext uri="{FF2B5EF4-FFF2-40B4-BE49-F238E27FC236}">
-                <a16:creationId xmlns:a16="http://schemas.microsoft.com/office/drawing/2014/main" id="{7A165B00-DDB7-4F47-9B7A-CA2DE3D94044}"/>
+                <a16:creationId xmlns:a16="http://schemas.microsoft.com/office/drawing/2014/main" id="{02CDCA70-9D05-4C25-A5E3-35876EAA41D9}"/>
               </a:ext>
             </a:extLst>
           </p:cNvPr>
@@ -11099,7 +11099,7 @@
           <p:cNvPr id="18" name="">
             <a:extLst xmlns:a="http://schemas.openxmlformats.org/drawingml/2006/main">
               <a:ext uri="{FF2B5EF4-FFF2-40B4-BE49-F238E27FC236}">
-                <a16:creationId xmlns:a16="http://schemas.microsoft.com/office/drawing/2014/main" id="{4BFC47A0-8642-45D6-93E0-7F7FBA828F39}"/>
+                <a16:creationId xmlns:a16="http://schemas.microsoft.com/office/drawing/2014/main" id="{2DB0DE46-1AF9-4311-8D04-02752D195F0A}"/>
               </a:ext>
             </a:extLst>
           </p:cNvPr>
@@ -11157,7 +11157,7 @@
           <p:cNvPr id="19" name="">
             <a:extLst xmlns:a="http://schemas.openxmlformats.org/drawingml/2006/main">
               <a:ext uri="{FF2B5EF4-FFF2-40B4-BE49-F238E27FC236}">
-                <a16:creationId xmlns:a16="http://schemas.microsoft.com/office/drawing/2014/main" id="{C32BF99B-7743-461B-ADFB-C0BAFB269604}"/>
+                <a16:creationId xmlns:a16="http://schemas.microsoft.com/office/drawing/2014/main" id="{A844B8FA-3ED1-45EA-A77A-4F1B10FFD49E}"/>
               </a:ext>
             </a:extLst>
           </p:cNvPr>
@@ -11213,7 +11213,7 @@
     </p:spTree>
     <p:extLst>
       <p:ext uri="{BB962C8B-B14F-4D97-AF65-F5344CB8AC3E}">
-        <p14:creationId xmlns:p14="http://schemas.microsoft.com/office/powerpoint/2010/main" val="377779410"/>
+        <p14:creationId xmlns:p14="http://schemas.microsoft.com/office/powerpoint/2010/main" val="1440041063"/>
       </p:ext>
     </p:extLst>
   </p:cSld>
@@ -11244,7 +11244,7 @@
           <p:cNvPr id="27" name="">
             <a:extLst xmlns:a="http://schemas.openxmlformats.org/drawingml/2006/main">
               <a:ext uri="{FF2B5EF4-FFF2-40B4-BE49-F238E27FC236}">
-                <a16:creationId xmlns:a16="http://schemas.microsoft.com/office/drawing/2014/main" id="{C1600601-210A-4B7C-8B96-A1DE718B0CC9}"/>
+                <a16:creationId xmlns:a16="http://schemas.microsoft.com/office/drawing/2014/main" id="{5C63413F-B12A-4591-AFA7-46017EE264D7}"/>
               </a:ext>
             </a:extLst>
           </p:cNvPr>
@@ -11302,7 +11302,7 @@
           <p:cNvPr id="2" name="">
             <a:extLst xmlns:a="http://schemas.openxmlformats.org/drawingml/2006/main">
               <a:ext uri="{FF2B5EF4-FFF2-40B4-BE49-F238E27FC236}">
-                <a16:creationId xmlns:a16="http://schemas.microsoft.com/office/drawing/2014/main" id="{517C2B89-D6BA-4F32-9509-CCC96CAFA5BC}"/>
+                <a16:creationId xmlns:a16="http://schemas.microsoft.com/office/drawing/2014/main" id="{84C3A88F-35E2-4658-9364-9C5410804D46}"/>
               </a:ext>
             </a:extLst>
           </p:cNvPr>
@@ -11360,7 +11360,7 @@
           <p:cNvPr id="3" name="">
             <a:extLst xmlns:a="http://schemas.openxmlformats.org/drawingml/2006/main">
               <a:ext uri="{FF2B5EF4-FFF2-40B4-BE49-F238E27FC236}">
-                <a16:creationId xmlns:a16="http://schemas.microsoft.com/office/drawing/2014/main" id="{41E80DBC-3A4E-4FE4-A429-F9905A9CC705}"/>
+                <a16:creationId xmlns:a16="http://schemas.microsoft.com/office/drawing/2014/main" id="{CA234B78-E355-4FD7-82B4-0492DF84D9A6}"/>
               </a:ext>
             </a:extLst>
           </p:cNvPr>
@@ -11391,7 +11391,7 @@
           <p:cNvPr id="4" name="">
             <a:extLst xmlns:a="http://schemas.openxmlformats.org/drawingml/2006/main">
               <a:ext uri="{FF2B5EF4-FFF2-40B4-BE49-F238E27FC236}">
-                <a16:creationId xmlns:a16="http://schemas.microsoft.com/office/drawing/2014/main" id="{0EBC0AD5-E79E-41ED-86EF-FAD070FACAAD}"/>
+                <a16:creationId xmlns:a16="http://schemas.microsoft.com/office/drawing/2014/main" id="{DE294831-4024-4ACA-8B39-DEF54172B487}"/>
               </a:ext>
             </a:extLst>
           </p:cNvPr>
@@ -11449,7 +11449,7 @@
           <p:cNvPr id="5" name="">
             <a:extLst xmlns:a="http://schemas.openxmlformats.org/drawingml/2006/main">
               <a:ext uri="{FF2B5EF4-FFF2-40B4-BE49-F238E27FC236}">
-                <a16:creationId xmlns:a16="http://schemas.microsoft.com/office/drawing/2014/main" id="{F0BF80BE-A6F5-4D9E-877E-C9364B0BB511}"/>
+                <a16:creationId xmlns:a16="http://schemas.microsoft.com/office/drawing/2014/main" id="{10CB9F1D-0D21-4F64-9DDA-106845621294}"/>
               </a:ext>
             </a:extLst>
           </p:cNvPr>
@@ -11507,7 +11507,7 @@
           <p:cNvPr id="6" name="">
             <a:extLst xmlns:a="http://schemas.openxmlformats.org/drawingml/2006/main">
               <a:ext uri="{FF2B5EF4-FFF2-40B4-BE49-F238E27FC236}">
-                <a16:creationId xmlns:a16="http://schemas.microsoft.com/office/drawing/2014/main" id="{AB19DE58-2D15-4368-8083-DB5D470AC430}"/>
+                <a16:creationId xmlns:a16="http://schemas.microsoft.com/office/drawing/2014/main" id="{A4F23CD2-D0C9-4F81-9F1C-9E170CE32418}"/>
               </a:ext>
             </a:extLst>
           </p:cNvPr>
@@ -11565,7 +11565,7 @@
           <p:cNvPr id="7" name="">
             <a:extLst xmlns:a="http://schemas.openxmlformats.org/drawingml/2006/main">
               <a:ext uri="{FF2B5EF4-FFF2-40B4-BE49-F238E27FC236}">
-                <a16:creationId xmlns:a16="http://schemas.microsoft.com/office/drawing/2014/main" id="{A409D381-0736-45E3-A588-BE8C00593B4C}"/>
+                <a16:creationId xmlns:a16="http://schemas.microsoft.com/office/drawing/2014/main" id="{662AF22D-A482-4E45-80D4-0D906FB8CE0B}"/>
               </a:ext>
             </a:extLst>
           </p:cNvPr>
@@ -11623,7 +11623,7 @@
           <p:cNvPr id="8" name="">
             <a:extLst xmlns:a="http://schemas.openxmlformats.org/drawingml/2006/main">
               <a:ext uri="{FF2B5EF4-FFF2-40B4-BE49-F238E27FC236}">
-                <a16:creationId xmlns:a16="http://schemas.microsoft.com/office/drawing/2014/main" id="{EC2A51B6-74D2-4819-9E4F-FA449DAB25B3}"/>
+                <a16:creationId xmlns:a16="http://schemas.microsoft.com/office/drawing/2014/main" id="{46413232-3C1A-4D50-BE93-B9683FD2B386}"/>
               </a:ext>
             </a:extLst>
           </p:cNvPr>
@@ -11654,7 +11654,7 @@
           <p:cNvPr id="9" name="">
             <a:extLst xmlns:a="http://schemas.openxmlformats.org/drawingml/2006/main">
               <a:ext uri="{FF2B5EF4-FFF2-40B4-BE49-F238E27FC236}">
-                <a16:creationId xmlns:a16="http://schemas.microsoft.com/office/drawing/2014/main" id="{F73C7781-F75B-4B64-B683-943CEE521D4D}"/>
+                <a16:creationId xmlns:a16="http://schemas.microsoft.com/office/drawing/2014/main" id="{86B6B8D7-0FB6-43A6-8025-B85E1CE0B0D4}"/>
               </a:ext>
             </a:extLst>
           </p:cNvPr>
@@ -11712,7 +11712,7 @@
           <p:cNvPr id="10" name="">
             <a:extLst xmlns:a="http://schemas.openxmlformats.org/drawingml/2006/main">
               <a:ext uri="{FF2B5EF4-FFF2-40B4-BE49-F238E27FC236}">
-                <a16:creationId xmlns:a16="http://schemas.microsoft.com/office/drawing/2014/main" id="{3BF23234-7A89-44B8-A48C-0AFE2ACC9F1B}"/>
+                <a16:creationId xmlns:a16="http://schemas.microsoft.com/office/drawing/2014/main" id="{1032D2DB-FC3A-422A-B94D-1DBC1416F7A2}"/>
               </a:ext>
             </a:extLst>
           </p:cNvPr>
@@ -11770,7 +11770,7 @@
           <p:cNvPr id="11" name="">
             <a:extLst xmlns:a="http://schemas.openxmlformats.org/drawingml/2006/main">
               <a:ext uri="{FF2B5EF4-FFF2-40B4-BE49-F238E27FC236}">
-                <a16:creationId xmlns:a16="http://schemas.microsoft.com/office/drawing/2014/main" id="{42D57BEF-326F-4552-8D9B-D118CB27EFF0}"/>
+                <a16:creationId xmlns:a16="http://schemas.microsoft.com/office/drawing/2014/main" id="{BF36EC1D-232A-46AC-9912-46356CD63597}"/>
               </a:ext>
             </a:extLst>
           </p:cNvPr>
@@ -11828,7 +11828,7 @@
           <p:cNvPr id="12" name="">
             <a:extLst xmlns:a="http://schemas.openxmlformats.org/drawingml/2006/main">
               <a:ext uri="{FF2B5EF4-FFF2-40B4-BE49-F238E27FC236}">
-                <a16:creationId xmlns:a16="http://schemas.microsoft.com/office/drawing/2014/main" id="{8475213F-8036-4667-9ADC-2C628021EA5C}"/>
+                <a16:creationId xmlns:a16="http://schemas.microsoft.com/office/drawing/2014/main" id="{F9AF5FFD-FED2-481A-A727-BDBBA0B9A33E}"/>
               </a:ext>
             </a:extLst>
           </p:cNvPr>
@@ -11886,7 +11886,7 @@
           <p:cNvPr id="13" name="">
             <a:extLst xmlns:a="http://schemas.openxmlformats.org/drawingml/2006/main">
               <a:ext uri="{FF2B5EF4-FFF2-40B4-BE49-F238E27FC236}">
-                <a16:creationId xmlns:a16="http://schemas.microsoft.com/office/drawing/2014/main" id="{AAD308DC-DF18-4C75-89BF-7AB163C8F0E6}"/>
+                <a16:creationId xmlns:a16="http://schemas.microsoft.com/office/drawing/2014/main" id="{BB6D459A-E3C4-4A85-AA55-7572AAB9D8A1}"/>
               </a:ext>
             </a:extLst>
           </p:cNvPr>
@@ -11917,7 +11917,7 @@
           <p:cNvPr id="14" name="">
             <a:extLst xmlns:a="http://schemas.openxmlformats.org/drawingml/2006/main">
               <a:ext uri="{FF2B5EF4-FFF2-40B4-BE49-F238E27FC236}">
-                <a16:creationId xmlns:a16="http://schemas.microsoft.com/office/drawing/2014/main" id="{A3FF2347-B748-4494-A2FE-034796CD4A8F}"/>
+                <a16:creationId xmlns:a16="http://schemas.microsoft.com/office/drawing/2014/main" id="{1F9D8473-A087-4A58-B4A7-763782592F8A}"/>
               </a:ext>
             </a:extLst>
           </p:cNvPr>
@@ -11975,7 +11975,7 @@
           <p:cNvPr id="15" name="">
             <a:extLst xmlns:a="http://schemas.openxmlformats.org/drawingml/2006/main">
               <a:ext uri="{FF2B5EF4-FFF2-40B4-BE49-F238E27FC236}">
-                <a16:creationId xmlns:a16="http://schemas.microsoft.com/office/drawing/2014/main" id="{43E67604-C8A9-4B99-B44B-B6551454FFCA}"/>
+                <a16:creationId xmlns:a16="http://schemas.microsoft.com/office/drawing/2014/main" id="{B61929F5-3E2B-4257-A8D9-997D6DFF32D1}"/>
               </a:ext>
             </a:extLst>
           </p:cNvPr>
@@ -12033,7 +12033,7 @@
           <p:cNvPr id="16" name="">
             <a:extLst xmlns:a="http://schemas.openxmlformats.org/drawingml/2006/main">
               <a:ext uri="{FF2B5EF4-FFF2-40B4-BE49-F238E27FC236}">
-                <a16:creationId xmlns:a16="http://schemas.microsoft.com/office/drawing/2014/main" id="{1CF28402-1416-428D-A775-1261115EA1D1}"/>
+                <a16:creationId xmlns:a16="http://schemas.microsoft.com/office/drawing/2014/main" id="{CEC6A4A9-A17D-4CAF-8F43-DE630ED9155B}"/>
               </a:ext>
             </a:extLst>
           </p:cNvPr>
@@ -12091,7 +12091,7 @@
           <p:cNvPr id="17" name="">
             <a:extLst xmlns:a="http://schemas.openxmlformats.org/drawingml/2006/main">
               <a:ext uri="{FF2B5EF4-FFF2-40B4-BE49-F238E27FC236}">
-                <a16:creationId xmlns:a16="http://schemas.microsoft.com/office/drawing/2014/main" id="{924542E7-36FF-4C3F-AD6B-3AD0F48898F2}"/>
+                <a16:creationId xmlns:a16="http://schemas.microsoft.com/office/drawing/2014/main" id="{46B4BF9C-E461-4B7F-B376-B650E9157BD3}"/>
               </a:ext>
             </a:extLst>
           </p:cNvPr>
@@ -12149,7 +12149,7 @@
           <p:cNvPr id="18" name="">
             <a:extLst xmlns:a="http://schemas.openxmlformats.org/drawingml/2006/main">
               <a:ext uri="{FF2B5EF4-FFF2-40B4-BE49-F238E27FC236}">
-                <a16:creationId xmlns:a16="http://schemas.microsoft.com/office/drawing/2014/main" id="{74C358D1-B238-4177-AEAB-7AD6B39E59A6}"/>
+                <a16:creationId xmlns:a16="http://schemas.microsoft.com/office/drawing/2014/main" id="{67621139-E33F-486C-BC31-C1F9BD146A35}"/>
               </a:ext>
             </a:extLst>
           </p:cNvPr>
@@ -12180,7 +12180,7 @@
           <p:cNvPr id="19" name="">
             <a:extLst xmlns:a="http://schemas.openxmlformats.org/drawingml/2006/main">
               <a:ext uri="{FF2B5EF4-FFF2-40B4-BE49-F238E27FC236}">
-                <a16:creationId xmlns:a16="http://schemas.microsoft.com/office/drawing/2014/main" id="{C750B717-1D13-440C-B766-EEEBDB42A795}"/>
+                <a16:creationId xmlns:a16="http://schemas.microsoft.com/office/drawing/2014/main" id="{63D4BEEF-DE88-448A-8E70-37560A3C756B}"/>
               </a:ext>
             </a:extLst>
           </p:cNvPr>
@@ -12238,7 +12238,7 @@
           <p:cNvPr id="20" name="">
             <a:extLst xmlns:a="http://schemas.openxmlformats.org/drawingml/2006/main">
               <a:ext uri="{FF2B5EF4-FFF2-40B4-BE49-F238E27FC236}">
-                <a16:creationId xmlns:a16="http://schemas.microsoft.com/office/drawing/2014/main" id="{0A756DB1-8794-48BB-84FA-26E4ABB46D36}"/>
+                <a16:creationId xmlns:a16="http://schemas.microsoft.com/office/drawing/2014/main" id="{289BB1C4-6704-4DF4-981D-5AFF91F7022F}"/>
               </a:ext>
             </a:extLst>
           </p:cNvPr>
@@ -12296,7 +12296,7 @@
           <p:cNvPr id="21" name="">
             <a:extLst xmlns:a="http://schemas.openxmlformats.org/drawingml/2006/main">
               <a:ext uri="{FF2B5EF4-FFF2-40B4-BE49-F238E27FC236}">
-                <a16:creationId xmlns:a16="http://schemas.microsoft.com/office/drawing/2014/main" id="{4AEA1DD7-894A-48C4-9C8A-25EB29DD6E1D}"/>
+                <a16:creationId xmlns:a16="http://schemas.microsoft.com/office/drawing/2014/main" id="{0F05821F-4299-46E0-A734-DCC967867FAC}"/>
               </a:ext>
             </a:extLst>
           </p:cNvPr>
@@ -12354,7 +12354,7 @@
           <p:cNvPr id="22" name="">
             <a:extLst xmlns:a="http://schemas.openxmlformats.org/drawingml/2006/main">
               <a:ext uri="{FF2B5EF4-FFF2-40B4-BE49-F238E27FC236}">
-                <a16:creationId xmlns:a16="http://schemas.microsoft.com/office/drawing/2014/main" id="{3A206A41-CE23-44BD-B027-A992B48C349B}"/>
+                <a16:creationId xmlns:a16="http://schemas.microsoft.com/office/drawing/2014/main" id="{4C1F3DFE-25C6-4BB8-858A-8132F7244B6C}"/>
               </a:ext>
             </a:extLst>
           </p:cNvPr>
@@ -12387,7 +12387,7 @@
           <p:cNvPr id="23" name="">
             <a:extLst xmlns:a="http://schemas.openxmlformats.org/drawingml/2006/main">
               <a:ext uri="{FF2B5EF4-FFF2-40B4-BE49-F238E27FC236}">
-                <a16:creationId xmlns:a16="http://schemas.microsoft.com/office/drawing/2014/main" id="{B5F2F75F-DDE3-4E5B-98B0-1999FC9702A2}"/>
+                <a16:creationId xmlns:a16="http://schemas.microsoft.com/office/drawing/2014/main" id="{9F75962A-0A24-4024-BD4B-CCB27DEC8546}"/>
               </a:ext>
             </a:extLst>
           </p:cNvPr>
@@ -12445,7 +12445,7 @@
           <p:cNvPr id="24" name="">
             <a:extLst xmlns:a="http://schemas.openxmlformats.org/drawingml/2006/main">
               <a:ext uri="{FF2B5EF4-FFF2-40B4-BE49-F238E27FC236}">
-                <a16:creationId xmlns:a16="http://schemas.microsoft.com/office/drawing/2014/main" id="{86451894-0C60-4BF5-AEDF-1471DE698E97}"/>
+                <a16:creationId xmlns:a16="http://schemas.microsoft.com/office/drawing/2014/main" id="{7C4F9BD4-1A57-4DFC-B309-893868E59E10}"/>
               </a:ext>
             </a:extLst>
           </p:cNvPr>
@@ -12476,7 +12476,7 @@
           <p:cNvPr id="25" name="">
             <a:extLst xmlns:a="http://schemas.openxmlformats.org/drawingml/2006/main">
               <a:ext uri="{FF2B5EF4-FFF2-40B4-BE49-F238E27FC236}">
-                <a16:creationId xmlns:a16="http://schemas.microsoft.com/office/drawing/2014/main" id="{BB8726F6-571F-4FF4-B7AA-8881F5E06AFA}"/>
+                <a16:creationId xmlns:a16="http://schemas.microsoft.com/office/drawing/2014/main" id="{DC931463-034C-4639-A012-A61A375A9469}"/>
               </a:ext>
             </a:extLst>
           </p:cNvPr>
@@ -12534,7 +12534,7 @@
           <p:cNvPr id="26" name="">
             <a:extLst xmlns:a="http://schemas.openxmlformats.org/drawingml/2006/main">
               <a:ext uri="{FF2B5EF4-FFF2-40B4-BE49-F238E27FC236}">
-                <a16:creationId xmlns:a16="http://schemas.microsoft.com/office/drawing/2014/main" id="{FAF091FB-38EF-4103-8B12-729E87A9C008}"/>
+                <a16:creationId xmlns:a16="http://schemas.microsoft.com/office/drawing/2014/main" id="{F556997B-ACD2-443D-89B9-F13E91C806A9}"/>
               </a:ext>
             </a:extLst>
           </p:cNvPr>
@@ -12590,7 +12590,7 @@
     </p:spTree>
     <p:extLst>
       <p:ext uri="{BB962C8B-B14F-4D97-AF65-F5344CB8AC3E}">
-        <p14:creationId xmlns:p14="http://schemas.microsoft.com/office/powerpoint/2010/main" val="979805565"/>
+        <p14:creationId xmlns:p14="http://schemas.microsoft.com/office/powerpoint/2010/main" val="198265791"/>
       </p:ext>
     </p:extLst>
   </p:cSld>
@@ -12621,7 +12621,7 @@
           <p:cNvPr id="20" name="">
             <a:extLst xmlns:a="http://schemas.openxmlformats.org/drawingml/2006/main">
               <a:ext uri="{FF2B5EF4-FFF2-40B4-BE49-F238E27FC236}">
-                <a16:creationId xmlns:a16="http://schemas.microsoft.com/office/drawing/2014/main" id="{BC1D1AF8-4C59-4E2C-B88C-42303CE067F8}"/>
+                <a16:creationId xmlns:a16="http://schemas.microsoft.com/office/drawing/2014/main" id="{C96838A1-BCF4-4870-8F93-DE33B19DBE41}"/>
               </a:ext>
             </a:extLst>
           </p:cNvPr>
@@ -12679,7 +12679,7 @@
           <p:cNvPr id="2" name="">
             <a:extLst xmlns:a="http://schemas.openxmlformats.org/drawingml/2006/main">
               <a:ext uri="{FF2B5EF4-FFF2-40B4-BE49-F238E27FC236}">
-                <a16:creationId xmlns:a16="http://schemas.microsoft.com/office/drawing/2014/main" id="{F1B4FAAB-A502-4310-BE42-730AE7B8078A}"/>
+                <a16:creationId xmlns:a16="http://schemas.microsoft.com/office/drawing/2014/main" id="{A4FDC5B8-476E-425F-A716-2298E724B842}"/>
               </a:ext>
             </a:extLst>
           </p:cNvPr>
@@ -12737,7 +12737,7 @@
           <p:cNvPr id="3" name="">
             <a:extLst xmlns:a="http://schemas.openxmlformats.org/drawingml/2006/main">
               <a:ext uri="{FF2B5EF4-FFF2-40B4-BE49-F238E27FC236}">
-                <a16:creationId xmlns:a16="http://schemas.microsoft.com/office/drawing/2014/main" id="{398E5652-FF17-4EBB-97B4-5F58EDF4597B}"/>
+                <a16:creationId xmlns:a16="http://schemas.microsoft.com/office/drawing/2014/main" id="{520F2EB4-0036-4F83-A057-495349A4F029}"/>
               </a:ext>
             </a:extLst>
           </p:cNvPr>
@@ -12795,7 +12795,7 @@
           <p:cNvPr id="4" name="">
             <a:extLst xmlns:a="http://schemas.openxmlformats.org/drawingml/2006/main">
               <a:ext uri="{FF2B5EF4-FFF2-40B4-BE49-F238E27FC236}">
-                <a16:creationId xmlns:a16="http://schemas.microsoft.com/office/drawing/2014/main" id="{A370DADB-232B-436F-B3A6-425E6D6F88DD}"/>
+                <a16:creationId xmlns:a16="http://schemas.microsoft.com/office/drawing/2014/main" id="{4ECAFBD4-FEC8-4451-8BBA-E6AE96B73BAD}"/>
               </a:ext>
             </a:extLst>
           </p:cNvPr>
@@ -12826,7 +12826,7 @@
           <p:cNvPr id="5" name="">
             <a:extLst xmlns:a="http://schemas.openxmlformats.org/drawingml/2006/main">
               <a:ext uri="{FF2B5EF4-FFF2-40B4-BE49-F238E27FC236}">
-                <a16:creationId xmlns:a16="http://schemas.microsoft.com/office/drawing/2014/main" id="{DDA07C30-935F-45D0-B4F7-80EF92CA2719}"/>
+                <a16:creationId xmlns:a16="http://schemas.microsoft.com/office/drawing/2014/main" id="{BB9BCBD8-879F-4E66-ACE9-8B6FC977B749}"/>
               </a:ext>
             </a:extLst>
           </p:cNvPr>
@@ -12884,7 +12884,7 @@
           <p:cNvPr id="6" name="">
             <a:extLst xmlns:a="http://schemas.openxmlformats.org/drawingml/2006/main">
               <a:ext uri="{FF2B5EF4-FFF2-40B4-BE49-F238E27FC236}">
-                <a16:creationId xmlns:a16="http://schemas.microsoft.com/office/drawing/2014/main" id="{CB037FFC-4AE6-49C4-8CE7-D8E0D1E07AC8}"/>
+                <a16:creationId xmlns:a16="http://schemas.microsoft.com/office/drawing/2014/main" id="{47FAF62E-3070-47B1-854F-035B27A9CD7C}"/>
               </a:ext>
             </a:extLst>
           </p:cNvPr>
@@ -12942,7 +12942,7 @@
           <p:cNvPr id="7" name="">
             <a:extLst xmlns:a="http://schemas.openxmlformats.org/drawingml/2006/main">
               <a:ext uri="{FF2B5EF4-FFF2-40B4-BE49-F238E27FC236}">
-                <a16:creationId xmlns:a16="http://schemas.microsoft.com/office/drawing/2014/main" id="{31CD73F7-6DC8-4280-A12F-B91E59B50CBA}"/>
+                <a16:creationId xmlns:a16="http://schemas.microsoft.com/office/drawing/2014/main" id="{30F9DD4C-A276-4E68-A6EE-5B90EAF4523C}"/>
               </a:ext>
             </a:extLst>
           </p:cNvPr>
@@ -13000,7 +13000,7 @@
           <p:cNvPr id="8" name="">
             <a:extLst xmlns:a="http://schemas.openxmlformats.org/drawingml/2006/main">
               <a:ext uri="{FF2B5EF4-FFF2-40B4-BE49-F238E27FC236}">
-                <a16:creationId xmlns:a16="http://schemas.microsoft.com/office/drawing/2014/main" id="{8D809D8A-708A-49E3-9C31-D5ED9D7E5091}"/>
+                <a16:creationId xmlns:a16="http://schemas.microsoft.com/office/drawing/2014/main" id="{4F7D3415-A019-415C-A172-87D8E5EB920A}"/>
               </a:ext>
             </a:extLst>
           </p:cNvPr>
@@ -13031,7 +13031,7 @@
           <p:cNvPr id="9" name="">
             <a:extLst xmlns:a="http://schemas.openxmlformats.org/drawingml/2006/main">
               <a:ext uri="{FF2B5EF4-FFF2-40B4-BE49-F238E27FC236}">
-                <a16:creationId xmlns:a16="http://schemas.microsoft.com/office/drawing/2014/main" id="{A51BA767-181C-48F8-9798-EDBA4C04226F}"/>
+                <a16:creationId xmlns:a16="http://schemas.microsoft.com/office/drawing/2014/main" id="{DFDAC5D7-0626-40EA-9209-3B4920B16F01}"/>
               </a:ext>
             </a:extLst>
           </p:cNvPr>
@@ -13089,7 +13089,7 @@
           <p:cNvPr id="10" name="">
             <a:extLst xmlns:a="http://schemas.openxmlformats.org/drawingml/2006/main">
               <a:ext uri="{FF2B5EF4-FFF2-40B4-BE49-F238E27FC236}">
-                <a16:creationId xmlns:a16="http://schemas.microsoft.com/office/drawing/2014/main" id="{42804AA9-D07F-4817-A536-EE0F28365154}"/>
+                <a16:creationId xmlns:a16="http://schemas.microsoft.com/office/drawing/2014/main" id="{A2B02CCE-596A-49FC-800D-678E7FD8B33E}"/>
               </a:ext>
             </a:extLst>
           </p:cNvPr>
@@ -13147,7 +13147,7 @@
           <p:cNvPr id="11" name="">
             <a:extLst xmlns:a="http://schemas.openxmlformats.org/drawingml/2006/main">
               <a:ext uri="{FF2B5EF4-FFF2-40B4-BE49-F238E27FC236}">
-                <a16:creationId xmlns:a16="http://schemas.microsoft.com/office/drawing/2014/main" id="{21D2B133-41D1-429C-8A45-BFF5E8C5B655}"/>
+                <a16:creationId xmlns:a16="http://schemas.microsoft.com/office/drawing/2014/main" id="{E971386D-6EA1-48BA-A371-B033CF418F29}"/>
               </a:ext>
             </a:extLst>
           </p:cNvPr>
@@ -13205,7 +13205,7 @@
           <p:cNvPr id="12" name="">
             <a:extLst xmlns:a="http://schemas.openxmlformats.org/drawingml/2006/main">
               <a:ext uri="{FF2B5EF4-FFF2-40B4-BE49-F238E27FC236}">
-                <a16:creationId xmlns:a16="http://schemas.microsoft.com/office/drawing/2014/main" id="{8AE7DDD3-E4DD-4D6C-BC56-912C04157CDF}"/>
+                <a16:creationId xmlns:a16="http://schemas.microsoft.com/office/drawing/2014/main" id="{C19A4161-C4E9-462E-93AF-0FFB24C8D2C4}"/>
               </a:ext>
             </a:extLst>
           </p:cNvPr>
@@ -13263,7 +13263,7 @@
           <p:cNvPr id="13" name="">
             <a:extLst xmlns:a="http://schemas.openxmlformats.org/drawingml/2006/main">
               <a:ext uri="{FF2B5EF4-FFF2-40B4-BE49-F238E27FC236}">
-                <a16:creationId xmlns:a16="http://schemas.microsoft.com/office/drawing/2014/main" id="{9420D5B1-B62B-4213-A08D-CB5D0DBE5F58}"/>
+                <a16:creationId xmlns:a16="http://schemas.microsoft.com/office/drawing/2014/main" id="{18DCDF23-5C3B-4886-BA52-28F3B7B84C39}"/>
               </a:ext>
             </a:extLst>
           </p:cNvPr>
@@ -13294,7 +13294,7 @@
           <p:cNvPr id="14" name="">
             <a:extLst xmlns:a="http://schemas.openxmlformats.org/drawingml/2006/main">
               <a:ext uri="{FF2B5EF4-FFF2-40B4-BE49-F238E27FC236}">
-                <a16:creationId xmlns:a16="http://schemas.microsoft.com/office/drawing/2014/main" id="{BDA9D413-541D-48CF-8043-970C4A4154A4}"/>
+                <a16:creationId xmlns:a16="http://schemas.microsoft.com/office/drawing/2014/main" id="{085A26FD-D78C-430C-BFD7-E9B7DD258E6C}"/>
               </a:ext>
             </a:extLst>
           </p:cNvPr>
@@ -13352,7 +13352,7 @@
           <p:cNvPr id="15" name="">
             <a:extLst xmlns:a="http://schemas.openxmlformats.org/drawingml/2006/main">
               <a:ext uri="{FF2B5EF4-FFF2-40B4-BE49-F238E27FC236}">
-                <a16:creationId xmlns:a16="http://schemas.microsoft.com/office/drawing/2014/main" id="{0DB91F92-E0F3-4033-B6D8-4E674F316B1C}"/>
+                <a16:creationId xmlns:a16="http://schemas.microsoft.com/office/drawing/2014/main" id="{6F96425C-F4FE-4FED-963F-3C646F5236B1}"/>
               </a:ext>
             </a:extLst>
           </p:cNvPr>
@@ -13410,7 +13410,7 @@
           <p:cNvPr id="16" name="">
             <a:extLst xmlns:a="http://schemas.openxmlformats.org/drawingml/2006/main">
               <a:ext uri="{FF2B5EF4-FFF2-40B4-BE49-F238E27FC236}">
-                <a16:creationId xmlns:a16="http://schemas.microsoft.com/office/drawing/2014/main" id="{C9964AD9-A4CC-499B-BA85-5553D2E34C01}"/>
+                <a16:creationId xmlns:a16="http://schemas.microsoft.com/office/drawing/2014/main" id="{833C99C7-2D25-4437-80CB-F93B7825613E}"/>
               </a:ext>
             </a:extLst>
           </p:cNvPr>
@@ -13468,7 +13468,7 @@
           <p:cNvPr id="17" name="">
             <a:extLst xmlns:a="http://schemas.openxmlformats.org/drawingml/2006/main">
               <a:ext uri="{FF2B5EF4-FFF2-40B4-BE49-F238E27FC236}">
-                <a16:creationId xmlns:a16="http://schemas.microsoft.com/office/drawing/2014/main" id="{020A6131-ABD9-4304-A2A3-26D9CE6D80AE}"/>
+                <a16:creationId xmlns:a16="http://schemas.microsoft.com/office/drawing/2014/main" id="{33FE7452-E1DE-4BD0-B2F0-F9146A0FBC5C}"/>
               </a:ext>
             </a:extLst>
           </p:cNvPr>
@@ -13499,7 +13499,7 @@
           <p:cNvPr id="18" name="">
             <a:extLst xmlns:a="http://schemas.openxmlformats.org/drawingml/2006/main">
               <a:ext uri="{FF2B5EF4-FFF2-40B4-BE49-F238E27FC236}">
-                <a16:creationId xmlns:a16="http://schemas.microsoft.com/office/drawing/2014/main" id="{0282FE4C-45EE-4288-9925-646C50BB9A3A}"/>
+                <a16:creationId xmlns:a16="http://schemas.microsoft.com/office/drawing/2014/main" id="{29549907-CF7D-4304-8750-A5D3722A5066}"/>
               </a:ext>
             </a:extLst>
           </p:cNvPr>
@@ -13557,7 +13557,7 @@
           <p:cNvPr id="19" name="">
             <a:extLst xmlns:a="http://schemas.openxmlformats.org/drawingml/2006/main">
               <a:ext uri="{FF2B5EF4-FFF2-40B4-BE49-F238E27FC236}">
-                <a16:creationId xmlns:a16="http://schemas.microsoft.com/office/drawing/2014/main" id="{9583C691-DFA7-43E6-8796-9D22AF13C5F6}"/>
+                <a16:creationId xmlns:a16="http://schemas.microsoft.com/office/drawing/2014/main" id="{4C71C016-5ACF-4C0C-B34E-7109D1DFCDF1}"/>
               </a:ext>
             </a:extLst>
           </p:cNvPr>
@@ -13613,7 +13613,7 @@
     </p:spTree>
     <p:extLst>
       <p:ext uri="{BB962C8B-B14F-4D97-AF65-F5344CB8AC3E}">
-        <p14:creationId xmlns:p14="http://schemas.microsoft.com/office/powerpoint/2010/main" val="43035181"/>
+        <p14:creationId xmlns:p14="http://schemas.microsoft.com/office/powerpoint/2010/main" val="629104608"/>
       </p:ext>
     </p:extLst>
   </p:cSld>

</xml_diff>